<commit_message>
Link the published repository from the presentation
</commit_message>
<xml_diff>
--- a/presentation/Healthcare_ECG_CA3_Presentation.pptx
+++ b/presentation/Healthcare_ECG_CA3_Presentation.pptx
@@ -2,26 +2,26 @@
 <file path=ppt/presentation.xml><?xml version="1.0" encoding="utf-8"?>
 <p:presentation xmlns:p="http://schemas.openxmlformats.org/presentationml/2006/main">
   <p:sldMasterIdLst>
-    <p:sldMasterId xmlns:r="http://schemas.openxmlformats.org/officeDocument/2006/relationships" id="2147483648" r:id="Rdcb2cd7acc3b4fd6"/>
+    <p:sldMasterId xmlns:r="http://schemas.openxmlformats.org/officeDocument/2006/relationships" id="2147483648" r:id="R45446b334aca4d42"/>
   </p:sldMasterIdLst>
   <p:notesMasterIdLst>
-    <p:notesMasterId xmlns:r="http://schemas.openxmlformats.org/officeDocument/2006/relationships" r:id="Rf4969d72563a4494"/>
+    <p:notesMasterId xmlns:r="http://schemas.openxmlformats.org/officeDocument/2006/relationships" r:id="Re585c60fb9114ad5"/>
   </p:notesMasterIdLst>
   <p:sldIdLst>
-    <p:sldId xmlns:r="http://schemas.openxmlformats.org/officeDocument/2006/relationships" id="256" r:id="Rc796b8a6f3634735"/>
-    <p:sldId xmlns:r="http://schemas.openxmlformats.org/officeDocument/2006/relationships" id="257" r:id="Rdacfcbb35b3c495c"/>
-    <p:sldId xmlns:r="http://schemas.openxmlformats.org/officeDocument/2006/relationships" id="258" r:id="Rc5750ab389ff4bc9"/>
-    <p:sldId xmlns:r="http://schemas.openxmlformats.org/officeDocument/2006/relationships" id="259" r:id="Rf9a8be4611264f6a"/>
-    <p:sldId xmlns:r="http://schemas.openxmlformats.org/officeDocument/2006/relationships" id="260" r:id="Ra9c291d9fb884ed2"/>
-    <p:sldId xmlns:r="http://schemas.openxmlformats.org/officeDocument/2006/relationships" id="261" r:id="R71eb5ac1907047bb"/>
-    <p:sldId xmlns:r="http://schemas.openxmlformats.org/officeDocument/2006/relationships" id="262" r:id="R3ce8ed420d504edb"/>
-    <p:sldId xmlns:r="http://schemas.openxmlformats.org/officeDocument/2006/relationships" id="263" r:id="Rebb7932c5f084f48"/>
-    <p:sldId xmlns:r="http://schemas.openxmlformats.org/officeDocument/2006/relationships" id="264" r:id="R1d7e41a9c0b94e76"/>
-    <p:sldId xmlns:r="http://schemas.openxmlformats.org/officeDocument/2006/relationships" id="265" r:id="R0fbc1550ac714e5f"/>
-    <p:sldId xmlns:r="http://schemas.openxmlformats.org/officeDocument/2006/relationships" id="266" r:id="R130349b8fe3e49ed"/>
-    <p:sldId xmlns:r="http://schemas.openxmlformats.org/officeDocument/2006/relationships" id="267" r:id="R6bc074b3e1d64523"/>
-    <p:sldId xmlns:r="http://schemas.openxmlformats.org/officeDocument/2006/relationships" id="268" r:id="Reb0f5026c0034bd4"/>
-    <p:sldId xmlns:r="http://schemas.openxmlformats.org/officeDocument/2006/relationships" id="269" r:id="R561871c612ac4d33"/>
+    <p:sldId xmlns:r="http://schemas.openxmlformats.org/officeDocument/2006/relationships" id="256" r:id="Re224507f22f646d5"/>
+    <p:sldId xmlns:r="http://schemas.openxmlformats.org/officeDocument/2006/relationships" id="257" r:id="Rbc5d1d7872ff4fda"/>
+    <p:sldId xmlns:r="http://schemas.openxmlformats.org/officeDocument/2006/relationships" id="258" r:id="Rcd213c58bb7347e2"/>
+    <p:sldId xmlns:r="http://schemas.openxmlformats.org/officeDocument/2006/relationships" id="259" r:id="R8bd55ff9405e4d01"/>
+    <p:sldId xmlns:r="http://schemas.openxmlformats.org/officeDocument/2006/relationships" id="260" r:id="R8d605d9b0d0c48b4"/>
+    <p:sldId xmlns:r="http://schemas.openxmlformats.org/officeDocument/2006/relationships" id="261" r:id="R812f56d6e8dc4da5"/>
+    <p:sldId xmlns:r="http://schemas.openxmlformats.org/officeDocument/2006/relationships" id="262" r:id="R154cec1348ce4e1b"/>
+    <p:sldId xmlns:r="http://schemas.openxmlformats.org/officeDocument/2006/relationships" id="263" r:id="Rc33330d49e714a9f"/>
+    <p:sldId xmlns:r="http://schemas.openxmlformats.org/officeDocument/2006/relationships" id="264" r:id="R4987ae3227164648"/>
+    <p:sldId xmlns:r="http://schemas.openxmlformats.org/officeDocument/2006/relationships" id="265" r:id="R4f58363eec1845de"/>
+    <p:sldId xmlns:r="http://schemas.openxmlformats.org/officeDocument/2006/relationships" id="266" r:id="R2ec6f8e9523f4994"/>
+    <p:sldId xmlns:r="http://schemas.openxmlformats.org/officeDocument/2006/relationships" id="267" r:id="R4d04b376dbaa4969"/>
+    <p:sldId xmlns:r="http://schemas.openxmlformats.org/officeDocument/2006/relationships" id="268" r:id="Rb89a8629cb784461"/>
+    <p:sldId xmlns:r="http://schemas.openxmlformats.org/officeDocument/2006/relationships" id="269" r:id="Rf261f459bd174cad"/>
   </p:sldIdLst>
   <p:sldSz cx="12192000" cy="6858000"/>
   <p:notesSz cx="6858000" cy="9144000"/>
@@ -735,7 +735,7 @@
           <a:lstStyle xmlns:a="http://schemas.openxmlformats.org/drawingml/2006/main"/>
           <a:p xmlns:a="http://schemas.openxmlformats.org/drawingml/2006/main">
             <a:r>
-              <a:t>Sources: results/aggregate-results.json, results/evidence-verification.json, Healthcare_ECG_Colab.ipynb, README.md and the IEEE report. Internal evaluation on one historical dataset. No external hospital test, prospective study, probability calibration, subgroup fairness assessment or clinician explanation review. The notebook recomputes saved metrics without retraining. Future work: external validation, calibration, subgroup analysis and expert-reviewed explanations. GitHub repository publication is still pending and no repository URL is invented.</a:t>
+              <a:t>Sources: results/aggregate-results.json, results/evidence-verification.json, Healthcare_ECG_Colab.ipynb, README.md and the IEEE report. Internal evaluation on one historical dataset. No external hospital test, prospective study, probability calibration, subgroup fairness assessment or clinician explanation review. The notebook recomputes saved metrics without retraining. Future work: external validation, calibration, subgroup analysis and expert-reviewed explanations. GitHub repository: https://github.com/Tanvib24/explainable-ecg-classification.</a:t>
             </a:r>
           </a:p>
         </p:txBody>
@@ -1412,7 +1412,7 @@
           <p:cNvPr id="3" name="Title">
             <a:extLst xmlns:a="http://schemas.openxmlformats.org/drawingml/2006/main">
               <a:ext uri="{FF2B5EF4-FFF2-40B4-BE49-F238E27FC236}">
-                <a16:creationId xmlns:a16="http://schemas.microsoft.com/office/drawing/2014/main" id="{FF05AF2C-9D3A-4326-8F55-98EC4761951E}"/>
+                <a16:creationId xmlns:a16="http://schemas.microsoft.com/office/drawing/2014/main" id="{79AAC68B-C69A-431B-8459-BF466E08A909}"/>
               </a:ext>
             </a:extLst>
           </p:cNvPr>
@@ -1641,7 +1641,7 @@
           <p:cNvPr id="2" name="Subtitle">
             <a:extLst xmlns:a="http://schemas.openxmlformats.org/drawingml/2006/main">
               <a:ext uri="{FF2B5EF4-FFF2-40B4-BE49-F238E27FC236}">
-                <a16:creationId xmlns:a16="http://schemas.microsoft.com/office/drawing/2014/main" id="{894B395C-0D51-45D8-B6F7-F2E9FE5119F7}"/>
+                <a16:creationId xmlns:a16="http://schemas.microsoft.com/office/drawing/2014/main" id="{840515AF-D6B6-4B21-A281-5E07D37F790F}"/>
               </a:ext>
             </a:extLst>
           </p:cNvPr>
@@ -1887,7 +1887,7 @@
           <p:cNvPr id="2" name="Section title">
             <a:extLst xmlns:a="http://schemas.openxmlformats.org/drawingml/2006/main">
               <a:ext uri="{FF2B5EF4-FFF2-40B4-BE49-F238E27FC236}">
-                <a16:creationId xmlns:a16="http://schemas.microsoft.com/office/drawing/2014/main" id="{9A1352BB-AEB9-4261-B3A3-984607AD6C3B}"/>
+                <a16:creationId xmlns:a16="http://schemas.microsoft.com/office/drawing/2014/main" id="{64A531FC-0D9B-4455-85F9-A7EE754D45D8}"/>
               </a:ext>
             </a:extLst>
           </p:cNvPr>
@@ -2133,7 +2133,7 @@
           <p:cNvPr id="3" name="Title">
             <a:extLst xmlns:a="http://schemas.openxmlformats.org/drawingml/2006/main">
               <a:ext uri="{FF2B5EF4-FFF2-40B4-BE49-F238E27FC236}">
-                <a16:creationId xmlns:a16="http://schemas.microsoft.com/office/drawing/2014/main" id="{D53E7C97-0855-4F6F-9EFD-2E7AD207ED16}"/>
+                <a16:creationId xmlns:a16="http://schemas.microsoft.com/office/drawing/2014/main" id="{C2A22A4A-5418-4B15-B555-5FEA40ADF3D4}"/>
               </a:ext>
             </a:extLst>
           </p:cNvPr>
@@ -2362,7 +2362,7 @@
           <p:cNvPr id="2" name="Body">
             <a:extLst xmlns:a="http://schemas.openxmlformats.org/drawingml/2006/main">
               <a:ext uri="{FF2B5EF4-FFF2-40B4-BE49-F238E27FC236}">
-                <a16:creationId xmlns:a16="http://schemas.microsoft.com/office/drawing/2014/main" id="{154F9223-0CEB-48EF-B821-36E12C731D18}"/>
+                <a16:creationId xmlns:a16="http://schemas.microsoft.com/office/drawing/2014/main" id="{284FC746-1BB9-4C6F-9F03-4457B4837849}"/>
               </a:ext>
             </a:extLst>
           </p:cNvPr>
@@ -2608,7 +2608,7 @@
           <p:cNvPr id="4" name="Title">
             <a:extLst xmlns:a="http://schemas.openxmlformats.org/drawingml/2006/main">
               <a:ext uri="{FF2B5EF4-FFF2-40B4-BE49-F238E27FC236}">
-                <a16:creationId xmlns:a16="http://schemas.microsoft.com/office/drawing/2014/main" id="{43CBDF17-7B89-4C45-AABC-547EA51D1647}"/>
+                <a16:creationId xmlns:a16="http://schemas.microsoft.com/office/drawing/2014/main" id="{6FCC1B4B-DD0A-49F3-ABAB-D9E4859C754B}"/>
               </a:ext>
             </a:extLst>
           </p:cNvPr>
@@ -2837,7 +2837,7 @@
           <p:cNvPr id="2" name="Left column">
             <a:extLst xmlns:a="http://schemas.openxmlformats.org/drawingml/2006/main">
               <a:ext uri="{FF2B5EF4-FFF2-40B4-BE49-F238E27FC236}">
-                <a16:creationId xmlns:a16="http://schemas.microsoft.com/office/drawing/2014/main" id="{E48C4EC4-D52B-49D0-B480-024C5B4AB2A0}"/>
+                <a16:creationId xmlns:a16="http://schemas.microsoft.com/office/drawing/2014/main" id="{4C23E04F-7FA3-49F3-9C21-5AEC15D26076}"/>
               </a:ext>
             </a:extLst>
           </p:cNvPr>
@@ -3066,7 +3066,7 @@
           <p:cNvPr id="3" name="Right column">
             <a:extLst xmlns:a="http://schemas.openxmlformats.org/drawingml/2006/main">
               <a:ext uri="{FF2B5EF4-FFF2-40B4-BE49-F238E27FC236}">
-                <a16:creationId xmlns:a16="http://schemas.microsoft.com/office/drawing/2014/main" id="{27D1D6D8-5C62-443D-88C8-F313FAEC3740}"/>
+                <a16:creationId xmlns:a16="http://schemas.microsoft.com/office/drawing/2014/main" id="{B9EE0E16-5930-444F-95B8-91FCDACDFF9D}"/>
               </a:ext>
             </a:extLst>
           </p:cNvPr>
@@ -3312,7 +3312,7 @@
           <p:cNvPr id="3" name="Title">
             <a:extLst xmlns:a="http://schemas.openxmlformats.org/drawingml/2006/main">
               <a:ext uri="{FF2B5EF4-FFF2-40B4-BE49-F238E27FC236}">
-                <a16:creationId xmlns:a16="http://schemas.microsoft.com/office/drawing/2014/main" id="{559C4B0F-D75A-4DFF-975E-F01026E29169}"/>
+                <a16:creationId xmlns:a16="http://schemas.microsoft.com/office/drawing/2014/main" id="{4B420A75-66D4-4FFB-A54A-32D7A5DC57C5}"/>
               </a:ext>
             </a:extLst>
           </p:cNvPr>
@@ -3541,7 +3541,7 @@
           <p:cNvPr id="2" name="Left column">
             <a:extLst xmlns:a="http://schemas.openxmlformats.org/drawingml/2006/main">
               <a:ext uri="{FF2B5EF4-FFF2-40B4-BE49-F238E27FC236}">
-                <a16:creationId xmlns:a16="http://schemas.microsoft.com/office/drawing/2014/main" id="{F3F0A61A-CF06-4262-8931-5088E8B0BE95}"/>
+                <a16:creationId xmlns:a16="http://schemas.microsoft.com/office/drawing/2014/main" id="{3C6E72F8-5CC4-496F-9CAC-AB86BF08878D}"/>
               </a:ext>
             </a:extLst>
           </p:cNvPr>
@@ -3808,12 +3808,12 @@
   </p:cSld>
   <p:clrMap bg1="lt1" tx1="dk1" bg2="lt2" tx2="dk2" accent1="accent1" accent2="accent2" accent3="accent3" accent4="accent4" accent5="accent5" accent6="accent6" hlink="hlink" folHlink="folHlink"/>
   <p:sldLayoutIdLst>
-    <p:sldLayoutId xmlns:r="http://schemas.openxmlformats.org/officeDocument/2006/relationships" id="2147483649" r:id="Rb96853e569254d90"/>
-    <p:sldLayoutId xmlns:r="http://schemas.openxmlformats.org/officeDocument/2006/relationships" id="2147483650" r:id="R3dcb47034fb54c1d"/>
-    <p:sldLayoutId xmlns:r="http://schemas.openxmlformats.org/officeDocument/2006/relationships" id="2147483651" r:id="R60b4cee3eccc47dc"/>
-    <p:sldLayoutId xmlns:r="http://schemas.openxmlformats.org/officeDocument/2006/relationships" id="2147483652" r:id="R5974a5ed8c324966"/>
-    <p:sldLayoutId xmlns:r="http://schemas.openxmlformats.org/officeDocument/2006/relationships" id="2147483653" r:id="R62fc873fa7624754"/>
-    <p:sldLayoutId xmlns:r="http://schemas.openxmlformats.org/officeDocument/2006/relationships" id="2147483654" r:id="Re5ee17188c2646a8"/>
+    <p:sldLayoutId xmlns:r="http://schemas.openxmlformats.org/officeDocument/2006/relationships" id="2147483649" r:id="R7039380100ef41c6"/>
+    <p:sldLayoutId xmlns:r="http://schemas.openxmlformats.org/officeDocument/2006/relationships" id="2147483650" r:id="R6cddf570e0cb4871"/>
+    <p:sldLayoutId xmlns:r="http://schemas.openxmlformats.org/officeDocument/2006/relationships" id="2147483651" r:id="Ra1fb37eb314a43ae"/>
+    <p:sldLayoutId xmlns:r="http://schemas.openxmlformats.org/officeDocument/2006/relationships" id="2147483652" r:id="R3a36be5114b74ee0"/>
+    <p:sldLayoutId xmlns:r="http://schemas.openxmlformats.org/officeDocument/2006/relationships" id="2147483653" r:id="Rdff60ec3d1204c12"/>
+    <p:sldLayoutId xmlns:r="http://schemas.openxmlformats.org/officeDocument/2006/relationships" id="2147483654" r:id="R82e07f9134234e5b"/>
   </p:sldLayoutIdLst>
   <p:txStyles>
     <p:titleStyle>
@@ -4588,7 +4588,7 @@
           <p:cNvPr id="6" name="CA3 MINI PROJECT">
             <a:extLst xmlns:a="http://schemas.openxmlformats.org/drawingml/2006/main">
               <a:ext uri="{FF2B5EF4-FFF2-40B4-BE49-F238E27FC236}">
-                <a16:creationId xmlns:a16="http://schemas.microsoft.com/office/drawing/2014/main" id="{53D61060-56DE-43E2-8BF6-E96F14628F34}"/>
+                <a16:creationId xmlns:a16="http://schemas.microsoft.com/office/drawing/2014/main" id="{224B52BE-363A-4C03-94C3-27B6382A1250}"/>
               </a:ext>
             </a:extLst>
           </p:cNvPr>
@@ -4746,7 +4746,7 @@
           <p:cNvPr id="2" name="Explainable Multi Label Classification&#10;of Car">
             <a:extLst xmlns:a="http://schemas.openxmlformats.org/drawingml/2006/main">
               <a:ext uri="{FF2B5EF4-FFF2-40B4-BE49-F238E27FC236}">
-                <a16:creationId xmlns:a16="http://schemas.microsoft.com/office/drawing/2014/main" id="{1831B174-27AF-4DBA-AB3B-B6D2693104B3}"/>
+                <a16:creationId xmlns:a16="http://schemas.microsoft.com/office/drawing/2014/main" id="{A2D51789-7207-4D09-92F0-43FA1EC7E903}"/>
               </a:ext>
             </a:extLst>
           </p:cNvPr>
@@ -4950,7 +4950,7 @@
           <p:cNvPr id="3" name="Using Lightweight Deep Learning">
             <a:extLst xmlns:a="http://schemas.openxmlformats.org/drawingml/2006/main">
               <a:ext uri="{FF2B5EF4-FFF2-40B4-BE49-F238E27FC236}">
-                <a16:creationId xmlns:a16="http://schemas.microsoft.com/office/drawing/2014/main" id="{06EC3380-D103-4842-9EFE-F8981C248107}"/>
+                <a16:creationId xmlns:a16="http://schemas.microsoft.com/office/drawing/2014/main" id="{97E732C6-5E4B-4CFB-A3C7-A44239C908D9}"/>
               </a:ext>
             </a:extLst>
           </p:cNvPr>
@@ -5108,7 +5108,7 @@
           <p:cNvPr id="4" name="Tanvi Bandebuche and Maheen Meshram">
             <a:extLst xmlns:a="http://schemas.openxmlformats.org/drawingml/2006/main">
               <a:ext uri="{FF2B5EF4-FFF2-40B4-BE49-F238E27FC236}">
-                <a16:creationId xmlns:a16="http://schemas.microsoft.com/office/drawing/2014/main" id="{D98979F1-78F8-4F35-B1B3-63C41377DF5C}"/>
+                <a16:creationId xmlns:a16="http://schemas.microsoft.com/office/drawing/2014/main" id="{910665C6-3906-4143-9326-5AFCD87973C6}"/>
               </a:ext>
             </a:extLst>
           </p:cNvPr>
@@ -5266,7 +5266,7 @@
           <p:cNvPr id="5" name="Computer Science and Engineering&#10;Symbiosis In">
             <a:extLst xmlns:a="http://schemas.openxmlformats.org/drawingml/2006/main">
               <a:ext uri="{FF2B5EF4-FFF2-40B4-BE49-F238E27FC236}">
-                <a16:creationId xmlns:a16="http://schemas.microsoft.com/office/drawing/2014/main" id="{182D7EE7-1886-442D-9D8C-67BD96AB5930}"/>
+                <a16:creationId xmlns:a16="http://schemas.microsoft.com/office/drawing/2014/main" id="{A6FEE1FB-4F01-4939-83C5-1F2CF09C252A}"/>
               </a:ext>
             </a:extLst>
           </p:cNvPr>
@@ -5445,7 +5445,7 @@
     </p:spTree>
     <p:extLst>
       <p:ext uri="{BB962C8B-B14F-4D97-AF65-F5344CB8AC3E}">
-        <p14:creationId xmlns:p14="http://schemas.microsoft.com/office/powerpoint/2010/main" val="853755781"/>
+        <p14:creationId xmlns:p14="http://schemas.microsoft.com/office/powerpoint/2010/main" val="749444300"/>
       </p:ext>
     </p:extLst>
   </p:cSld>
@@ -5476,7 +5476,7 @@
           <p:cNvPr id="7" name="CPU inference cost and model size">
             <a:extLst xmlns:a="http://schemas.openxmlformats.org/drawingml/2006/main">
               <a:ext uri="{FF2B5EF4-FFF2-40B4-BE49-F238E27FC236}">
-                <a16:creationId xmlns:a16="http://schemas.microsoft.com/office/drawing/2014/main" id="{8F857C51-04EC-4365-A48C-2596F33F561D}"/>
+                <a16:creationId xmlns:a16="http://schemas.microsoft.com/office/drawing/2014/main" id="{7E7AA53E-AA60-412E-A288-59329DE938E1}"/>
               </a:ext>
             </a:extLst>
           </p:cNvPr>
@@ -5634,7 +5634,7 @@
           <p:cNvPr id="2" name="10">
             <a:extLst xmlns:a="http://schemas.openxmlformats.org/drawingml/2006/main">
               <a:ext uri="{FF2B5EF4-FFF2-40B4-BE49-F238E27FC236}">
-                <a16:creationId xmlns:a16="http://schemas.microsoft.com/office/drawing/2014/main" id="{61A01C10-E96F-45CB-B3D9-7238B4B5F13B}"/>
+                <a16:creationId xmlns:a16="http://schemas.microsoft.com/office/drawing/2014/main" id="{27484C0E-6EF8-47BD-8239-8F0FEC9528A9}"/>
               </a:ext>
             </a:extLst>
           </p:cNvPr>
@@ -5792,7 +5792,7 @@
           <p:cNvPr id="3" name="Chart">
             <a:extLst xmlns:a="http://schemas.openxmlformats.org/drawingml/2006/main">
               <a:ext uri="{FF2B5EF4-FFF2-40B4-BE49-F238E27FC236}">
-                <a16:creationId xmlns:a16="http://schemas.microsoft.com/office/drawing/2014/main" id="{ED55F0A7-1D3E-435F-9AE0-F713FE399689}"/>
+                <a16:creationId xmlns:a16="http://schemas.microsoft.com/office/drawing/2014/main" id="{DF5D8848-FE79-4EBF-8C0A-9A7A93CB704D}"/>
               </a:ext>
             </a:extLst>
           </p:cNvPr>
@@ -5805,7 +5805,7 @@
         </p:xfrm>
         <a:graphic xmlns:a="http://schemas.openxmlformats.org/drawingml/2006/main">
           <a:graphicData uri="http://schemas.openxmlformats.org/drawingml/2006/chart">
-            <c:chart xmlns:r="http://schemas.openxmlformats.org/officeDocument/2006/relationships" xmlns:c="http://schemas.openxmlformats.org/drawingml/2006/chart" r:id="Raafb61484aa040a7"/>
+            <c:chart xmlns:r="http://schemas.openxmlformats.org/officeDocument/2006/relationships" xmlns:c="http://schemas.openxmlformats.org/drawingml/2006/chart" r:id="R283d544ec52c4f99"/>
           </a:graphicData>
         </a:graphic>
       </p:graphicFrame>
@@ -5814,7 +5814,7 @@
           <p:cNvPr id="4" name="Trainable parameters">
             <a:extLst xmlns:a="http://schemas.openxmlformats.org/drawingml/2006/main">
               <a:ext uri="{FF2B5EF4-FFF2-40B4-BE49-F238E27FC236}">
-                <a16:creationId xmlns:a16="http://schemas.microsoft.com/office/drawing/2014/main" id="{C4766191-0691-4E37-A0D9-8020B32E82EC}"/>
+                <a16:creationId xmlns:a16="http://schemas.microsoft.com/office/drawing/2014/main" id="{A4FEF4A9-A64B-4073-B04B-FFE40FCF3496}"/>
               </a:ext>
             </a:extLst>
           </p:cNvPr>
@@ -5972,7 +5972,7 @@
           <p:cNvPr id="5" name="Compact CNN&#10;221,573&#10;&#10;1D ResNet&#10;244,005&#10;&#10;Incep">
             <a:extLst xmlns:a="http://schemas.openxmlformats.org/drawingml/2006/main">
               <a:ext uri="{FF2B5EF4-FFF2-40B4-BE49-F238E27FC236}">
-                <a16:creationId xmlns:a16="http://schemas.microsoft.com/office/drawing/2014/main" id="{F2BA7ACE-70D9-4D71-852E-12B7EA89CADC}"/>
+                <a16:creationId xmlns:a16="http://schemas.microsoft.com/office/drawing/2014/main" id="{1EFF6D3F-E51B-4D4A-AD24-44E83DC0C5D5}"/>
               </a:ext>
             </a:extLst>
           </p:cNvPr>
@@ -6255,7 +6255,7 @@
           <p:cNvPr id="6" name="Batch size 1, four CPU threads. Average of ch">
             <a:extLst xmlns:a="http://schemas.openxmlformats.org/drawingml/2006/main">
               <a:ext uri="{FF2B5EF4-FFF2-40B4-BE49-F238E27FC236}">
-                <a16:creationId xmlns:a16="http://schemas.microsoft.com/office/drawing/2014/main" id="{1A883F51-779F-41A4-B105-A481FCFC93C7}"/>
+                <a16:creationId xmlns:a16="http://schemas.microsoft.com/office/drawing/2014/main" id="{DA542AA1-2F9F-4B34-9652-DF0E61E37E3E}"/>
               </a:ext>
             </a:extLst>
           </p:cNvPr>
@@ -6411,7 +6411,7 @@
     </p:spTree>
     <p:extLst>
       <p:ext uri="{BB962C8B-B14F-4D97-AF65-F5344CB8AC3E}">
-        <p14:creationId xmlns:p14="http://schemas.microsoft.com/office/powerpoint/2010/main" val="1191087570"/>
+        <p14:creationId xmlns:p14="http://schemas.microsoft.com/office/powerpoint/2010/main" val="913202161"/>
       </p:ext>
     </p:extLst>
   </p:cSld>
@@ -6442,7 +6442,7 @@
           <p:cNvPr id="8" name="Category errors and uncertainty">
             <a:extLst xmlns:a="http://schemas.openxmlformats.org/drawingml/2006/main">
               <a:ext uri="{FF2B5EF4-FFF2-40B4-BE49-F238E27FC236}">
-                <a16:creationId xmlns:a16="http://schemas.microsoft.com/office/drawing/2014/main" id="{2CF1851E-5F35-4FD1-9589-3F151327FD83}"/>
+                <a16:creationId xmlns:a16="http://schemas.microsoft.com/office/drawing/2014/main" id="{D7E2718B-28A2-493D-8BCE-6F6B161F60C9}"/>
               </a:ext>
             </a:extLst>
           </p:cNvPr>
@@ -6600,7 +6600,7 @@
           <p:cNvPr id="2" name="11">
             <a:extLst xmlns:a="http://schemas.openxmlformats.org/drawingml/2006/main">
               <a:ext uri="{FF2B5EF4-FFF2-40B4-BE49-F238E27FC236}">
-                <a16:creationId xmlns:a16="http://schemas.microsoft.com/office/drawing/2014/main" id="{BC4BACA7-E254-43FB-ACD4-FEC92845D724}"/>
+                <a16:creationId xmlns:a16="http://schemas.microsoft.com/office/drawing/2014/main" id="{30718745-B5EE-42B8-B224-7275C435A240}"/>
               </a:ext>
             </a:extLst>
           </p:cNvPr>
@@ -6758,7 +6758,7 @@
           <p:cNvPr id="3" name="">
             <a:extLst xmlns:a="http://schemas.openxmlformats.org/drawingml/2006/main">
               <a:ext uri="{FF2B5EF4-FFF2-40B4-BE49-F238E27FC236}">
-                <a16:creationId xmlns:a16="http://schemas.microsoft.com/office/drawing/2014/main" id="{AF38A5D6-8F51-435D-840C-C0E2A16A2E19}"/>
+                <a16:creationId xmlns:a16="http://schemas.microsoft.com/office/drawing/2014/main" id="{B592C367-09CA-49CA-8DF7-BBFCBA41D47B}"/>
               </a:ext>
             </a:extLst>
           </p:cNvPr>
@@ -6768,7 +6768,7 @@
           <p:nvPr/>
         </p:nvPicPr>
         <p:blipFill>
-          <a:blip xmlns:r="http://schemas.openxmlformats.org/officeDocument/2006/relationships" xmlns:a="http://schemas.openxmlformats.org/drawingml/2006/main" r:embed="R07680940b5dc40d6"/>
+          <a:blip xmlns:r="http://schemas.openxmlformats.org/officeDocument/2006/relationships" xmlns:a="http://schemas.openxmlformats.org/drawingml/2006/main" r:embed="Rc5ce59d5616641d8"/>
           <a:stretch xmlns:a="http://schemas.openxmlformats.org/drawingml/2006/main"/>
         </p:blipFill>
         <p:spPr>
@@ -6786,7 +6786,7 @@
           <p:cNvPr id="4" name="Hypertrophy is harder">
             <a:extLst xmlns:a="http://schemas.openxmlformats.org/drawingml/2006/main">
               <a:ext uri="{FF2B5EF4-FFF2-40B4-BE49-F238E27FC236}">
-                <a16:creationId xmlns:a16="http://schemas.microsoft.com/office/drawing/2014/main" id="{F46CE846-A5FE-40EB-8778-6D6455D3FC5F}"/>
+                <a16:creationId xmlns:a16="http://schemas.microsoft.com/office/drawing/2014/main" id="{AAC44018-EFFE-425F-8C06-A9E02CF934D0}"/>
               </a:ext>
             </a:extLst>
           </p:cNvPr>
@@ -6944,7 +6944,7 @@
           <p:cNvPr id="5" name="HYP F1: 0.592&#10;HYP recall: 0.615&#10;262 positive ">
             <a:extLst xmlns:a="http://schemas.openxmlformats.org/drawingml/2006/main">
               <a:ext uri="{FF2B5EF4-FFF2-40B4-BE49-F238E27FC236}">
-                <a16:creationId xmlns:a16="http://schemas.microsoft.com/office/drawing/2014/main" id="{D2B367ED-BD8E-4B5A-8C15-A157CBA7FC42}"/>
+                <a16:creationId xmlns:a16="http://schemas.microsoft.com/office/drawing/2014/main" id="{8483BCD6-D975-4AC2-8C5B-D8D0FB344CC5}"/>
               </a:ext>
             </a:extLst>
           </p:cNvPr>
@@ -7148,7 +7148,7 @@
           <p:cNvPr id="6" name="Selected checkpoint AUROC&#10;0.9178&#10;95% patient-">
             <a:extLst xmlns:a="http://schemas.openxmlformats.org/drawingml/2006/main">
               <a:ext uri="{FF2B5EF4-FFF2-40B4-BE49-F238E27FC236}">
-                <a16:creationId xmlns:a16="http://schemas.microsoft.com/office/drawing/2014/main" id="{17F6CF21-F7EE-410D-9C2B-51361BD7B520}"/>
+                <a16:creationId xmlns:a16="http://schemas.microsoft.com/office/drawing/2014/main" id="{F88E1E07-680F-4C6B-A59C-13EBA413A36A}"/>
               </a:ext>
             </a:extLst>
           </p:cNvPr>
@@ -7375,7 +7375,7 @@
           <p:cNvPr id="7" name="Precision–recall curves and category scores u">
             <a:extLst xmlns:a="http://schemas.openxmlformats.org/drawingml/2006/main">
               <a:ext uri="{FF2B5EF4-FFF2-40B4-BE49-F238E27FC236}">
-                <a16:creationId xmlns:a16="http://schemas.microsoft.com/office/drawing/2014/main" id="{640D6EE3-A4EC-4A01-91D6-CF989BD9C429}"/>
+                <a16:creationId xmlns:a16="http://schemas.microsoft.com/office/drawing/2014/main" id="{4EF77133-08A6-42EE-A49B-DFF5C9DD1998}"/>
               </a:ext>
             </a:extLst>
           </p:cNvPr>
@@ -7531,7 +7531,7 @@
     </p:spTree>
     <p:extLst>
       <p:ext uri="{BB962C8B-B14F-4D97-AF65-F5344CB8AC3E}">
-        <p14:creationId xmlns:p14="http://schemas.microsoft.com/office/powerpoint/2010/main" val="1679728538"/>
+        <p14:creationId xmlns:p14="http://schemas.microsoft.com/office/powerpoint/2010/main" val="82507872"/>
       </p:ext>
     </p:extLst>
   </p:cSld>
@@ -7562,7 +7562,7 @@
           <p:cNvPr id="8" name="Occlusion responses for an MI example">
             <a:extLst xmlns:a="http://schemas.openxmlformats.org/drawingml/2006/main">
               <a:ext uri="{FF2B5EF4-FFF2-40B4-BE49-F238E27FC236}">
-                <a16:creationId xmlns:a16="http://schemas.microsoft.com/office/drawing/2014/main" id="{6378F717-FE1D-473A-AAAE-C9867C4B7CD6}"/>
+                <a16:creationId xmlns:a16="http://schemas.microsoft.com/office/drawing/2014/main" id="{CAE6DD6C-FCF0-4969-B585-E5D3C9063F10}"/>
               </a:ext>
             </a:extLst>
           </p:cNvPr>
@@ -7720,7 +7720,7 @@
           <p:cNvPr id="2" name="12">
             <a:extLst xmlns:a="http://schemas.openxmlformats.org/drawingml/2006/main">
               <a:ext uri="{FF2B5EF4-FFF2-40B4-BE49-F238E27FC236}">
-                <a16:creationId xmlns:a16="http://schemas.microsoft.com/office/drawing/2014/main" id="{09CF9FB9-298B-4198-8291-A2F6DA8AFEB1}"/>
+                <a16:creationId xmlns:a16="http://schemas.microsoft.com/office/drawing/2014/main" id="{D014C677-B5E4-4CA8-989E-8CD68CD87322}"/>
               </a:ext>
             </a:extLst>
           </p:cNvPr>
@@ -7878,7 +7878,7 @@
           <p:cNvPr id="3" name="">
             <a:extLst xmlns:a="http://schemas.openxmlformats.org/drawingml/2006/main">
               <a:ext uri="{FF2B5EF4-FFF2-40B4-BE49-F238E27FC236}">
-                <a16:creationId xmlns:a16="http://schemas.microsoft.com/office/drawing/2014/main" id="{DC941CD1-5C76-4E9B-AE6D-C6F30A9ED78C}"/>
+                <a16:creationId xmlns:a16="http://schemas.microsoft.com/office/drawing/2014/main" id="{E281C801-D1AD-471E-99FE-59359B41908B}"/>
               </a:ext>
             </a:extLst>
           </p:cNvPr>
@@ -7888,7 +7888,7 @@
           <p:nvPr/>
         </p:nvPicPr>
         <p:blipFill>
-          <a:blip xmlns:r="http://schemas.openxmlformats.org/officeDocument/2006/relationships" xmlns:a="http://schemas.openxmlformats.org/drawingml/2006/main" r:embed="Rc0cc37bf7dbd4d03"/>
+          <a:blip xmlns:r="http://schemas.openxmlformats.org/officeDocument/2006/relationships" xmlns:a="http://schemas.openxmlformats.org/drawingml/2006/main" r:embed="R3198d03a95f24938"/>
           <a:stretch xmlns:a="http://schemas.openxmlformats.org/drawingml/2006/main"/>
         </p:blipFill>
         <p:spPr>
@@ -7906,7 +7906,7 @@
           <p:cNvPr id="4" name="ECG 162">
             <a:extLst xmlns:a="http://schemas.openxmlformats.org/drawingml/2006/main">
               <a:ext uri="{FF2B5EF4-FFF2-40B4-BE49-F238E27FC236}">
-                <a16:creationId xmlns:a16="http://schemas.microsoft.com/office/drawing/2014/main" id="{93B5D144-AA48-4325-8AAD-298EA6DD8964}"/>
+                <a16:creationId xmlns:a16="http://schemas.microsoft.com/office/drawing/2014/main" id="{BE3D949C-C116-4CBD-919E-385DE16B825C}"/>
               </a:ext>
             </a:extLst>
           </p:cNvPr>
@@ -8064,7 +8064,7 @@
           <p:cNvPr id="5" name="MI score: 0.860&#10;Decision threshold: 0.45">
             <a:extLst xmlns:a="http://schemas.openxmlformats.org/drawingml/2006/main">
               <a:ext uri="{FF2B5EF4-FFF2-40B4-BE49-F238E27FC236}">
-                <a16:creationId xmlns:a16="http://schemas.microsoft.com/office/drawing/2014/main" id="{8F1A3C62-EA69-465F-A965-37A3B1D6B30F}"/>
+                <a16:creationId xmlns:a16="http://schemas.microsoft.com/office/drawing/2014/main" id="{89B5939B-3756-4998-ACFB-018461145D88}"/>
               </a:ext>
             </a:extLst>
           </p:cNvPr>
@@ -8245,7 +8245,7 @@
           <p:cNvPr id="6" name="200 ms masking windows&#10;100 ms window stride&#10;B">
             <a:extLst xmlns:a="http://schemas.openxmlformats.org/drawingml/2006/main">
               <a:ext uri="{FF2B5EF4-FFF2-40B4-BE49-F238E27FC236}">
-                <a16:creationId xmlns:a16="http://schemas.microsoft.com/office/drawing/2014/main" id="{70D14223-4238-4C4E-A343-87AFCAF48AEC}"/>
+                <a16:creationId xmlns:a16="http://schemas.microsoft.com/office/drawing/2014/main" id="{CC5D22FF-293E-49BE-8F91-9E86A94C6404}"/>
               </a:ext>
             </a:extLst>
           </p:cNvPr>
@@ -8449,7 +8449,7 @@
           <p:cNvPr id="7" name="Occlusion measures model sensitivity. It does">
             <a:extLst xmlns:a="http://schemas.openxmlformats.org/drawingml/2006/main">
               <a:ext uri="{FF2B5EF4-FFF2-40B4-BE49-F238E27FC236}">
-                <a16:creationId xmlns:a16="http://schemas.microsoft.com/office/drawing/2014/main" id="{9E11188F-66B4-4FE5-80B6-F67349FF5489}"/>
+                <a16:creationId xmlns:a16="http://schemas.microsoft.com/office/drawing/2014/main" id="{3CEDE72A-5123-47E2-A2A7-33B474558127}"/>
               </a:ext>
             </a:extLst>
           </p:cNvPr>
@@ -8605,7 +8605,7 @@
     </p:spTree>
     <p:extLst>
       <p:ext uri="{BB962C8B-B14F-4D97-AF65-F5344CB8AC3E}">
-        <p14:creationId xmlns:p14="http://schemas.microsoft.com/office/powerpoint/2010/main" val="641407497"/>
+        <p14:creationId xmlns:p14="http://schemas.microsoft.com/office/powerpoint/2010/main" val="298475334"/>
       </p:ext>
     </p:extLst>
   </p:cSld>
@@ -8636,7 +8636,7 @@
           <p:cNvPr id="12" name="Conclusions and project deliverables">
             <a:extLst xmlns:a="http://schemas.openxmlformats.org/drawingml/2006/main">
               <a:ext uri="{FF2B5EF4-FFF2-40B4-BE49-F238E27FC236}">
-                <a16:creationId xmlns:a16="http://schemas.microsoft.com/office/drawing/2014/main" id="{BF81D7DF-4585-42C5-81AE-835D33CC51F6}"/>
+                <a16:creationId xmlns:a16="http://schemas.microsoft.com/office/drawing/2014/main" id="{8D46F3C3-9F07-43BC-A207-5B7356F609B8}"/>
               </a:ext>
             </a:extLst>
           </p:cNvPr>
@@ -8794,7 +8794,7 @@
           <p:cNvPr id="2" name="13">
             <a:extLst xmlns:a="http://schemas.openxmlformats.org/drawingml/2006/main">
               <a:ext uri="{FF2B5EF4-FFF2-40B4-BE49-F238E27FC236}">
-                <a16:creationId xmlns:a16="http://schemas.microsoft.com/office/drawing/2014/main" id="{30B9D9CB-1430-43CE-BB13-75E387BCCFF6}"/>
+                <a16:creationId xmlns:a16="http://schemas.microsoft.com/office/drawing/2014/main" id="{E2D754C5-86EB-4088-BC2D-4269932534F3}"/>
               </a:ext>
             </a:extLst>
           </p:cNvPr>
@@ -8952,7 +8952,7 @@
           <p:cNvPr id="3" name="Main finding">
             <a:extLst xmlns:a="http://schemas.openxmlformats.org/drawingml/2006/main">
               <a:ext uri="{FF2B5EF4-FFF2-40B4-BE49-F238E27FC236}">
-                <a16:creationId xmlns:a16="http://schemas.microsoft.com/office/drawing/2014/main" id="{655DD7DF-E88C-42A4-B809-672188874C46}"/>
+                <a16:creationId xmlns:a16="http://schemas.microsoft.com/office/drawing/2014/main" id="{A7910BF3-B317-4234-B766-1E8EBAF408D5}"/>
               </a:ext>
             </a:extLst>
           </p:cNvPr>
@@ -9110,7 +9110,7 @@
           <p:cNvPr id="4" name="Compact CNN: macro AUROC 0.9195&#10;and mean medi">
             <a:extLst xmlns:a="http://schemas.openxmlformats.org/drawingml/2006/main">
               <a:ext uri="{FF2B5EF4-FFF2-40B4-BE49-F238E27FC236}">
-                <a16:creationId xmlns:a16="http://schemas.microsoft.com/office/drawing/2014/main" id="{EBA03983-0C8B-4763-A00E-38B930A043C4}"/>
+                <a16:creationId xmlns:a16="http://schemas.microsoft.com/office/drawing/2014/main" id="{470EE6A0-FD88-4B8C-92AF-827783CB8FA6}"/>
               </a:ext>
             </a:extLst>
           </p:cNvPr>
@@ -9291,7 +9291,7 @@
           <p:cNvPr id="5" name="Evidence delivered">
             <a:extLst xmlns:a="http://schemas.openxmlformats.org/drawingml/2006/main">
               <a:ext uri="{FF2B5EF4-FFF2-40B4-BE49-F238E27FC236}">
-                <a16:creationId xmlns:a16="http://schemas.microsoft.com/office/drawing/2014/main" id="{8F86602D-A2D9-4E2A-B6FA-2FA2A6BEBE73}"/>
+                <a16:creationId xmlns:a16="http://schemas.microsoft.com/office/drawing/2014/main" id="{43987E83-6D94-4CED-8835-B7070E75CC54}"/>
               </a:ext>
             </a:extLst>
           </p:cNvPr>
@@ -9449,7 +9449,7 @@
           <p:cNvPr id="6" name="Checkpoints, predictions, and figures.&#10;Verifi">
             <a:extLst xmlns:a="http://schemas.openxmlformats.org/drawingml/2006/main">
               <a:ext uri="{FF2B5EF4-FFF2-40B4-BE49-F238E27FC236}">
-                <a16:creationId xmlns:a16="http://schemas.microsoft.com/office/drawing/2014/main" id="{F09B92B8-06FC-43AF-984D-2E5BE8115A9A}"/>
+                <a16:creationId xmlns:a16="http://schemas.microsoft.com/office/drawing/2014/main" id="{CBAE397B-38FC-4B0D-B498-1E9E6CBA9D6E}"/>
               </a:ext>
             </a:extLst>
           </p:cNvPr>
@@ -9630,7 +9630,7 @@
           <p:cNvPr id="7" name="Limits of the study">
             <a:extLst xmlns:a="http://schemas.openxmlformats.org/drawingml/2006/main">
               <a:ext uri="{FF2B5EF4-FFF2-40B4-BE49-F238E27FC236}">
-                <a16:creationId xmlns:a16="http://schemas.microsoft.com/office/drawing/2014/main" id="{4042AF4A-9EBC-4271-9877-42CFA88E09E5}"/>
+                <a16:creationId xmlns:a16="http://schemas.microsoft.com/office/drawing/2014/main" id="{50E85C1A-4BF2-425A-95CC-74C309E0275C}"/>
               </a:ext>
             </a:extLst>
           </p:cNvPr>
@@ -9788,7 +9788,7 @@
           <p:cNvPr id="8" name="One dataset and an internal test fold.&#10;No ext">
             <a:extLst xmlns:a="http://schemas.openxmlformats.org/drawingml/2006/main">
               <a:ext uri="{FF2B5EF4-FFF2-40B4-BE49-F238E27FC236}">
-                <a16:creationId xmlns:a16="http://schemas.microsoft.com/office/drawing/2014/main" id="{B1FB974F-BB7E-446F-AEDB-BA6B3894129C}"/>
+                <a16:creationId xmlns:a16="http://schemas.microsoft.com/office/drawing/2014/main" id="{07DC09E1-1331-480E-A203-B48BCCB0EB1F}"/>
               </a:ext>
             </a:extLst>
           </p:cNvPr>
@@ -9969,7 +9969,7 @@
           <p:cNvPr id="9" name="Next steps">
             <a:extLst xmlns:a="http://schemas.openxmlformats.org/drawingml/2006/main">
               <a:ext uri="{FF2B5EF4-FFF2-40B4-BE49-F238E27FC236}">
-                <a16:creationId xmlns:a16="http://schemas.microsoft.com/office/drawing/2014/main" id="{81715971-6C97-4695-9291-F0D521FE71D5}"/>
+                <a16:creationId xmlns:a16="http://schemas.microsoft.com/office/drawing/2014/main" id="{5F0A371A-8CBF-4AC7-883D-903BF7C18C38}"/>
               </a:ext>
             </a:extLst>
           </p:cNvPr>
@@ -10127,7 +10127,7 @@
           <p:cNvPr id="10" name="External testing and calibration.&#10;Subgroup ch">
             <a:extLst xmlns:a="http://schemas.openxmlformats.org/drawingml/2006/main">
               <a:ext uri="{FF2B5EF4-FFF2-40B4-BE49-F238E27FC236}">
-                <a16:creationId xmlns:a16="http://schemas.microsoft.com/office/drawing/2014/main" id="{260C23FA-C657-4F35-B05C-0D26565BCF93}"/>
+                <a16:creationId xmlns:a16="http://schemas.microsoft.com/office/drawing/2014/main" id="{E3424A3D-301D-44C0-9635-612F4060B8C5}"/>
               </a:ext>
             </a:extLst>
           </p:cNvPr>
@@ -10305,10 +10305,10 @@
       </p:sp>
       <p:sp>
         <p:nvSpPr>
-          <p:cNvPr id="11" name="The experiment supports a reproducible academ">
+          <p:cNvPr id="11" name="Code and notebook: github.com/Tanvib24/explai">
             <a:extLst xmlns:a="http://schemas.openxmlformats.org/drawingml/2006/main">
               <a:ext uri="{FF2B5EF4-FFF2-40B4-BE49-F238E27FC236}">
-                <a16:creationId xmlns:a16="http://schemas.microsoft.com/office/drawing/2014/main" id="{C15D015C-021F-43E8-97AD-FA358338A125}"/>
+                <a16:creationId xmlns:a16="http://schemas.microsoft.com/office/drawing/2014/main" id="{E8181530-2A09-4149-8C0B-AA41F69178A6}"/>
               </a:ext>
             </a:extLst>
           </p:cNvPr>
@@ -10456,7 +10456,7 @@
                 <a:ea typeface="Arial"/>
                 <a:cs typeface="Arial"/>
               </a:rPr>
-              <a:t>The experiment supports a reproducible academic baseline. GitHub publication remains pending.</a:t>
+              <a:t>Code and notebook: github.com/Tanvib24/explainable-ecg-classification</a:t>
             </a:r>
           </a:p>
         </p:txBody>
@@ -10464,7 +10464,7 @@
     </p:spTree>
     <p:extLst>
       <p:ext uri="{BB962C8B-B14F-4D97-AF65-F5344CB8AC3E}">
-        <p14:creationId xmlns:p14="http://schemas.microsoft.com/office/powerpoint/2010/main" val="614626764"/>
+        <p14:creationId xmlns:p14="http://schemas.microsoft.com/office/powerpoint/2010/main" val="913594694"/>
       </p:ext>
     </p:extLst>
   </p:cSld>
@@ -10495,7 +10495,7 @@
           <p:cNvPr id="12" name="Selected references">
             <a:extLst xmlns:a="http://schemas.openxmlformats.org/drawingml/2006/main">
               <a:ext uri="{FF2B5EF4-FFF2-40B4-BE49-F238E27FC236}">
-                <a16:creationId xmlns:a16="http://schemas.microsoft.com/office/drawing/2014/main" id="{E1D765E4-4578-45CC-9ED4-F82E748BCA7E}"/>
+                <a16:creationId xmlns:a16="http://schemas.microsoft.com/office/drawing/2014/main" id="{B47D1046-E4B3-47DA-8EBC-3E3CD60117A7}"/>
               </a:ext>
             </a:extLst>
           </p:cNvPr>
@@ -10653,7 +10653,7 @@
           <p:cNvPr id="2" name="14">
             <a:extLst xmlns:a="http://schemas.openxmlformats.org/drawingml/2006/main">
               <a:ext uri="{FF2B5EF4-FFF2-40B4-BE49-F238E27FC236}">
-                <a16:creationId xmlns:a16="http://schemas.microsoft.com/office/drawing/2014/main" id="{CB482F65-47FD-4A4B-B68D-BEF8D30E09E2}"/>
+                <a16:creationId xmlns:a16="http://schemas.microsoft.com/office/drawing/2014/main" id="{2547FD32-5CA3-49E8-8CC3-F3572819E7C1}"/>
               </a:ext>
             </a:extLst>
           </p:cNvPr>
@@ -10811,7 +10811,7 @@
           <p:cNvPr id="3" name="[1] Wagner et al. PTB-XL dataset. Scientific ">
             <a:extLst xmlns:a="http://schemas.openxmlformats.org/drawingml/2006/main">
               <a:ext uri="{FF2B5EF4-FFF2-40B4-BE49-F238E27FC236}">
-                <a16:creationId xmlns:a16="http://schemas.microsoft.com/office/drawing/2014/main" id="{E0507EB8-3018-48C1-AF4A-262D6E1C6D37}"/>
+                <a16:creationId xmlns:a16="http://schemas.microsoft.com/office/drawing/2014/main" id="{EA359FA2-DE2F-4EA8-9A39-48CF4333DC44}"/>
               </a:ext>
             </a:extLst>
           </p:cNvPr>
@@ -10969,7 +10969,7 @@
           <p:cNvPr id="4" name="[2] Strodthoff et al. Deep learning for ECG a">
             <a:extLst xmlns:a="http://schemas.openxmlformats.org/drawingml/2006/main">
               <a:ext uri="{FF2B5EF4-FFF2-40B4-BE49-F238E27FC236}">
-                <a16:creationId xmlns:a16="http://schemas.microsoft.com/office/drawing/2014/main" id="{EBAC66F5-B298-431B-94E9-ED6BAF32CB04}"/>
+                <a16:creationId xmlns:a16="http://schemas.microsoft.com/office/drawing/2014/main" id="{92A9249E-F234-42A3-A1CF-FF1C6E1C41AC}"/>
               </a:ext>
             </a:extLst>
           </p:cNvPr>
@@ -11127,7 +11127,7 @@
           <p:cNvPr id="5" name="[3] Mehari and Strodthoff. Self-supervised 12">
             <a:extLst xmlns:a="http://schemas.openxmlformats.org/drawingml/2006/main">
               <a:ext uri="{FF2B5EF4-FFF2-40B4-BE49-F238E27FC236}">
-                <a16:creationId xmlns:a16="http://schemas.microsoft.com/office/drawing/2014/main" id="{52AD2A16-5855-4EEB-97DE-9C2198FB83CC}"/>
+                <a16:creationId xmlns:a16="http://schemas.microsoft.com/office/drawing/2014/main" id="{40CF1A6A-D8FC-41E6-92C0-2CEBB3FA8633}"/>
               </a:ext>
             </a:extLst>
           </p:cNvPr>
@@ -11285,7 +11285,7 @@
           <p:cNvPr id="6" name="[6] van de Leur et al. Explainable ECG interp">
             <a:extLst xmlns:a="http://schemas.openxmlformats.org/drawingml/2006/main">
               <a:ext uri="{FF2B5EF4-FFF2-40B4-BE49-F238E27FC236}">
-                <a16:creationId xmlns:a16="http://schemas.microsoft.com/office/drawing/2014/main" id="{7DB70C8B-F324-4084-9330-C80073296868}"/>
+                <a16:creationId xmlns:a16="http://schemas.microsoft.com/office/drawing/2014/main" id="{38358295-8CE4-47FB-837D-DA63BEA097CB}"/>
               </a:ext>
             </a:extLst>
           </p:cNvPr>
@@ -11443,7 +11443,7 @@
           <p:cNvPr id="7" name="[8] Strodthoff et al. PTB-XL+ feature dataset">
             <a:extLst xmlns:a="http://schemas.openxmlformats.org/drawingml/2006/main">
               <a:ext uri="{FF2B5EF4-FFF2-40B4-BE49-F238E27FC236}">
-                <a16:creationId xmlns:a16="http://schemas.microsoft.com/office/drawing/2014/main" id="{C6406CEC-9354-451E-94FB-FCAAFEA0BF03}"/>
+                <a16:creationId xmlns:a16="http://schemas.microsoft.com/office/drawing/2014/main" id="{CE42A4DA-BEAB-4392-B328-5B3537B28941}"/>
               </a:ext>
             </a:extLst>
           </p:cNvPr>
@@ -11601,7 +11601,7 @@
           <p:cNvPr id="8" name="[15] Liu et al. Zero-shot ECG classification ">
             <a:extLst xmlns:a="http://schemas.openxmlformats.org/drawingml/2006/main">
               <a:ext uri="{FF2B5EF4-FFF2-40B4-BE49-F238E27FC236}">
-                <a16:creationId xmlns:a16="http://schemas.microsoft.com/office/drawing/2014/main" id="{D292153A-BC33-4E9B-8892-5F0B3FFCD419}"/>
+                <a16:creationId xmlns:a16="http://schemas.microsoft.com/office/drawing/2014/main" id="{DEE7DD4E-30D2-4E19-B3D0-CC10B2CA85D8}"/>
               </a:ext>
             </a:extLst>
           </p:cNvPr>
@@ -11759,7 +11759,7 @@
           <p:cNvPr id="9" name="[17] Liu et al. Knowledge-enhanced multimodal">
             <a:extLst xmlns:a="http://schemas.openxmlformats.org/drawingml/2006/main">
               <a:ext uri="{FF2B5EF4-FFF2-40B4-BE49-F238E27FC236}">
-                <a16:creationId xmlns:a16="http://schemas.microsoft.com/office/drawing/2014/main" id="{4A6CD1F8-B23F-43E6-89DD-9B2D64B70593}"/>
+                <a16:creationId xmlns:a16="http://schemas.microsoft.com/office/drawing/2014/main" id="{09205F39-BF22-4F23-97D0-9528E9143542}"/>
               </a:ext>
             </a:extLst>
           </p:cNvPr>
@@ -11917,7 +11917,7 @@
           <p:cNvPr id="10" name="[18] Wagner et al. PTB-XL version 1.0.3. Phys">
             <a:extLst xmlns:a="http://schemas.openxmlformats.org/drawingml/2006/main">
               <a:ext uri="{FF2B5EF4-FFF2-40B4-BE49-F238E27FC236}">
-                <a16:creationId xmlns:a16="http://schemas.microsoft.com/office/drawing/2014/main" id="{3E880FD9-F430-4DD0-BFD9-411907D444BB}"/>
+                <a16:creationId xmlns:a16="http://schemas.microsoft.com/office/drawing/2014/main" id="{D63239CE-7AFB-47D1-80E3-B2F337113A24}"/>
               </a:ext>
             </a:extLst>
           </p:cNvPr>
@@ -12075,7 +12075,7 @@
           <p:cNvPr id="11" name="Full citations and 15 recent research papers ">
             <a:extLst xmlns:a="http://schemas.openxmlformats.org/drawingml/2006/main">
               <a:ext uri="{FF2B5EF4-FFF2-40B4-BE49-F238E27FC236}">
-                <a16:creationId xmlns:a16="http://schemas.microsoft.com/office/drawing/2014/main" id="{3F6BB4A3-D949-4353-8893-C8C4000B59CE}"/>
+                <a16:creationId xmlns:a16="http://schemas.microsoft.com/office/drawing/2014/main" id="{10302F6B-3EC3-45F9-B1D7-92279DEE4C39}"/>
               </a:ext>
             </a:extLst>
           </p:cNvPr>
@@ -12231,7 +12231,7 @@
     </p:spTree>
     <p:extLst>
       <p:ext uri="{BB962C8B-B14F-4D97-AF65-F5344CB8AC3E}">
-        <p14:creationId xmlns:p14="http://schemas.microsoft.com/office/powerpoint/2010/main" val="217548828"/>
+        <p14:creationId xmlns:p14="http://schemas.microsoft.com/office/powerpoint/2010/main" val="1056308018"/>
       </p:ext>
     </p:extLst>
   </p:cSld>
@@ -12262,7 +12262,7 @@
           <p:cNvPr id="11" name="Problem and project objectives">
             <a:extLst xmlns:a="http://schemas.openxmlformats.org/drawingml/2006/main">
               <a:ext uri="{FF2B5EF4-FFF2-40B4-BE49-F238E27FC236}">
-                <a16:creationId xmlns:a16="http://schemas.microsoft.com/office/drawing/2014/main" id="{947CE543-0BB3-40A8-B7A1-E75ADCD90F15}"/>
+                <a16:creationId xmlns:a16="http://schemas.microsoft.com/office/drawing/2014/main" id="{44474190-A9E1-4FCA-8D6E-27F10BCA6A0C}"/>
               </a:ext>
             </a:extLst>
           </p:cNvPr>
@@ -12420,7 +12420,7 @@
           <p:cNvPr id="2" name="02">
             <a:extLst xmlns:a="http://schemas.openxmlformats.org/drawingml/2006/main">
               <a:ext uri="{FF2B5EF4-FFF2-40B4-BE49-F238E27FC236}">
-                <a16:creationId xmlns:a16="http://schemas.microsoft.com/office/drawing/2014/main" id="{874C12AA-CFB9-4B82-89E1-4EEFF8A625E4}"/>
+                <a16:creationId xmlns:a16="http://schemas.microsoft.com/office/drawing/2014/main" id="{E144C3C0-05BD-4C26-8A57-AA509F2BC447}"/>
               </a:ext>
             </a:extLst>
           </p:cNvPr>
@@ -12578,7 +12578,7 @@
           <p:cNvPr id="3" name="One ECG can carry several diagnostic labels.">
             <a:extLst xmlns:a="http://schemas.openxmlformats.org/drawingml/2006/main">
               <a:ext uri="{FF2B5EF4-FFF2-40B4-BE49-F238E27FC236}">
-                <a16:creationId xmlns:a16="http://schemas.microsoft.com/office/drawing/2014/main" id="{470084FF-9424-4A9C-B822-BD8EA650AB20}"/>
+                <a16:creationId xmlns:a16="http://schemas.microsoft.com/office/drawing/2014/main" id="{5260A028-785B-4D66-A9DD-B0EF357D791B}"/>
               </a:ext>
             </a:extLst>
           </p:cNvPr>
@@ -12736,7 +12736,7 @@
           <p:cNvPr id="4" name="01">
             <a:extLst xmlns:a="http://schemas.openxmlformats.org/drawingml/2006/main">
               <a:ext uri="{FF2B5EF4-FFF2-40B4-BE49-F238E27FC236}">
-                <a16:creationId xmlns:a16="http://schemas.microsoft.com/office/drawing/2014/main" id="{F86A13A0-F4B2-46CA-AAA7-2F809838E181}"/>
+                <a16:creationId xmlns:a16="http://schemas.microsoft.com/office/drawing/2014/main" id="{C645A356-6FF8-498C-B30E-DBA3ED2BED36}"/>
               </a:ext>
             </a:extLst>
           </p:cNvPr>
@@ -12894,7 +12894,7 @@
           <p:cNvPr id="5" name="Classify five diagnostic categories from a 10">
             <a:extLst xmlns:a="http://schemas.openxmlformats.org/drawingml/2006/main">
               <a:ext uri="{FF2B5EF4-FFF2-40B4-BE49-F238E27FC236}">
-                <a16:creationId xmlns:a16="http://schemas.microsoft.com/office/drawing/2014/main" id="{9EC42F7B-BA52-4064-922B-56F04824A37F}"/>
+                <a16:creationId xmlns:a16="http://schemas.microsoft.com/office/drawing/2014/main" id="{92CB2CC0-9AC8-4EA0-9E0A-885FE0C89C7A}"/>
               </a:ext>
             </a:extLst>
           </p:cNvPr>
@@ -13052,7 +13052,7 @@
           <p:cNvPr id="6" name="02">
             <a:extLst xmlns:a="http://schemas.openxmlformats.org/drawingml/2006/main">
               <a:ext uri="{FF2B5EF4-FFF2-40B4-BE49-F238E27FC236}">
-                <a16:creationId xmlns:a16="http://schemas.microsoft.com/office/drawing/2014/main" id="{B25C3E90-C1EF-41B3-8126-EFDE8D3F3D1A}"/>
+                <a16:creationId xmlns:a16="http://schemas.microsoft.com/office/drawing/2014/main" id="{34FD171A-CFE6-4152-BA33-CDB88796AF0D}"/>
               </a:ext>
             </a:extLst>
           </p:cNvPr>
@@ -13210,7 +13210,7 @@
           <p:cNvPr id="7" name="Compare a compact CNN with residual, inceptio">
             <a:extLst xmlns:a="http://schemas.openxmlformats.org/drawingml/2006/main">
               <a:ext uri="{FF2B5EF4-FFF2-40B4-BE49-F238E27FC236}">
-                <a16:creationId xmlns:a16="http://schemas.microsoft.com/office/drawing/2014/main" id="{277A4790-77F0-4D33-A975-47489C5191DD}"/>
+                <a16:creationId xmlns:a16="http://schemas.microsoft.com/office/drawing/2014/main" id="{25013A3C-72EE-4230-A94A-E35F68D5426E}"/>
               </a:ext>
             </a:extLst>
           </p:cNvPr>
@@ -13368,7 +13368,7 @@
           <p:cNvPr id="8" name="03">
             <a:extLst xmlns:a="http://schemas.openxmlformats.org/drawingml/2006/main">
               <a:ext uri="{FF2B5EF4-FFF2-40B4-BE49-F238E27FC236}">
-                <a16:creationId xmlns:a16="http://schemas.microsoft.com/office/drawing/2014/main" id="{7CA2285D-80FC-4D6D-8608-88390E786D96}"/>
+                <a16:creationId xmlns:a16="http://schemas.microsoft.com/office/drawing/2014/main" id="{E2B1561B-7728-4CBC-92B9-6494D173D874}"/>
               </a:ext>
             </a:extLst>
           </p:cNvPr>
@@ -13526,7 +13526,7 @@
           <p:cNvPr id="9" name="Measure held-out performance, CPU latency, an">
             <a:extLst xmlns:a="http://schemas.openxmlformats.org/drawingml/2006/main">
               <a:ext uri="{FF2B5EF4-FFF2-40B4-BE49-F238E27FC236}">
-                <a16:creationId xmlns:a16="http://schemas.microsoft.com/office/drawing/2014/main" id="{10F388E0-09AA-4152-901A-5B4110D71AAD}"/>
+                <a16:creationId xmlns:a16="http://schemas.microsoft.com/office/drawing/2014/main" id="{617DF479-47F8-4F0D-9D9A-D5B2C6A8C3C9}"/>
               </a:ext>
             </a:extLst>
           </p:cNvPr>
@@ -13684,7 +13684,7 @@
           <p:cNvPr id="10" name="NORM: normal ECG   MI: myocardial infarction ">
             <a:extLst xmlns:a="http://schemas.openxmlformats.org/drawingml/2006/main">
               <a:ext uri="{FF2B5EF4-FFF2-40B4-BE49-F238E27FC236}">
-                <a16:creationId xmlns:a16="http://schemas.microsoft.com/office/drawing/2014/main" id="{DC928215-0C3C-4054-B1BA-C9A248BC39F8}"/>
+                <a16:creationId xmlns:a16="http://schemas.microsoft.com/office/drawing/2014/main" id="{0CF5DDEB-501D-4BF6-91BF-94C6B5E97DA4}"/>
               </a:ext>
             </a:extLst>
           </p:cNvPr>
@@ -13840,7 +13840,7 @@
     </p:spTree>
     <p:extLst>
       <p:ext uri="{BB962C8B-B14F-4D97-AF65-F5344CB8AC3E}">
-        <p14:creationId xmlns:p14="http://schemas.microsoft.com/office/powerpoint/2010/main" val="1665826012"/>
+        <p14:creationId xmlns:p14="http://schemas.microsoft.com/office/powerpoint/2010/main" val="2069325153"/>
       </p:ext>
     </p:extLst>
   </p:cSld>
@@ -13871,7 +13871,7 @@
           <p:cNvPr id="6" name="Research context and study scope">
             <a:extLst xmlns:a="http://schemas.openxmlformats.org/drawingml/2006/main">
               <a:ext uri="{FF2B5EF4-FFF2-40B4-BE49-F238E27FC236}">
-                <a16:creationId xmlns:a16="http://schemas.microsoft.com/office/drawing/2014/main" id="{872C8FE3-7E36-405C-940D-832FFD16E6E3}"/>
+                <a16:creationId xmlns:a16="http://schemas.microsoft.com/office/drawing/2014/main" id="{54986E72-CBB0-49B1-AC57-C4C216EFD911}"/>
               </a:ext>
             </a:extLst>
           </p:cNvPr>
@@ -14029,7 +14029,7 @@
           <p:cNvPr id="2" name="03">
             <a:extLst xmlns:a="http://schemas.openxmlformats.org/drawingml/2006/main">
               <a:ext uri="{FF2B5EF4-FFF2-40B4-BE49-F238E27FC236}">
-                <a16:creationId xmlns:a16="http://schemas.microsoft.com/office/drawing/2014/main" id="{EAA994D1-C189-438F-8711-8D1FA7CDCA57}"/>
+                <a16:creationId xmlns:a16="http://schemas.microsoft.com/office/drawing/2014/main" id="{304A8703-5AA7-4E2D-9FB8-AF628BD2E88D}"/>
               </a:ext>
             </a:extLst>
           </p:cNvPr>
@@ -14187,7 +14187,7 @@
           <p:cNvPr id="3" name="">
             <a:extLst xmlns:a="http://schemas.openxmlformats.org/drawingml/2006/main">
               <a:ext uri="{FF2B5EF4-FFF2-40B4-BE49-F238E27FC236}">
-                <a16:creationId xmlns:a16="http://schemas.microsoft.com/office/drawing/2014/main" id="{CF9A7C77-1EF7-4118-8375-AA322EAB0D22}"/>
+                <a16:creationId xmlns:a16="http://schemas.microsoft.com/office/drawing/2014/main" id="{2052A2AF-2329-4813-91FE-AD0FB1E208F2}"/>
               </a:ext>
             </a:extLst>
           </p:cNvPr>
@@ -14627,7 +14627,7 @@
           <p:cNvPr id="4" name="Our scope: controlled supervised comparisons ">
             <a:extLst xmlns:a="http://schemas.openxmlformats.org/drawingml/2006/main">
               <a:ext uri="{FF2B5EF4-FFF2-40B4-BE49-F238E27FC236}">
-                <a16:creationId xmlns:a16="http://schemas.microsoft.com/office/drawing/2014/main" id="{BC9CD08A-7FFB-4FF6-9016-D178A525159C}"/>
+                <a16:creationId xmlns:a16="http://schemas.microsoft.com/office/drawing/2014/main" id="{454914A5-E1F0-41D2-B2CC-AB579742E732}"/>
               </a:ext>
             </a:extLst>
           </p:cNvPr>
@@ -14785,7 +14785,7 @@
           <p:cNvPr id="5" name="Citation numbers match the IEEE report. Publi">
             <a:extLst xmlns:a="http://schemas.openxmlformats.org/drawingml/2006/main">
               <a:ext uri="{FF2B5EF4-FFF2-40B4-BE49-F238E27FC236}">
-                <a16:creationId xmlns:a16="http://schemas.microsoft.com/office/drawing/2014/main" id="{48CDDB71-9C6D-4BCA-A830-AEA2DCEA4403}"/>
+                <a16:creationId xmlns:a16="http://schemas.microsoft.com/office/drawing/2014/main" id="{EC2826AE-4374-4FBD-92D4-F56959B9B83B}"/>
               </a:ext>
             </a:extLst>
           </p:cNvPr>
@@ -14941,7 +14941,7 @@
     </p:spTree>
     <p:extLst>
       <p:ext uri="{BB962C8B-B14F-4D97-AF65-F5344CB8AC3E}">
-        <p14:creationId xmlns:p14="http://schemas.microsoft.com/office/powerpoint/2010/main" val="437508247"/>
+        <p14:creationId xmlns:p14="http://schemas.microsoft.com/office/powerpoint/2010/main" val="797148400"/>
       </p:ext>
     </p:extLst>
   </p:cSld>
@@ -14972,7 +14972,7 @@
           <p:cNvPr id="7" name="PTB-XL dataset and patient partitions">
             <a:extLst xmlns:a="http://schemas.openxmlformats.org/drawingml/2006/main">
               <a:ext uri="{FF2B5EF4-FFF2-40B4-BE49-F238E27FC236}">
-                <a16:creationId xmlns:a16="http://schemas.microsoft.com/office/drawing/2014/main" id="{D5CC4727-D137-4BA3-926A-41A82AAFC504}"/>
+                <a16:creationId xmlns:a16="http://schemas.microsoft.com/office/drawing/2014/main" id="{A1316D5D-CB97-4E83-A8F7-9CEFF8F129BC}"/>
               </a:ext>
             </a:extLst>
           </p:cNvPr>
@@ -15130,7 +15130,7 @@
           <p:cNvPr id="2" name="04">
             <a:extLst xmlns:a="http://schemas.openxmlformats.org/drawingml/2006/main">
               <a:ext uri="{FF2B5EF4-FFF2-40B4-BE49-F238E27FC236}">
-                <a16:creationId xmlns:a16="http://schemas.microsoft.com/office/drawing/2014/main" id="{D8ED2944-842A-4655-B8D9-32A2E9C390D1}"/>
+                <a16:creationId xmlns:a16="http://schemas.microsoft.com/office/drawing/2014/main" id="{65A95BE1-39DA-4880-989E-C69177DF330F}"/>
               </a:ext>
             </a:extLst>
           </p:cNvPr>
@@ -15288,7 +15288,7 @@
           <p:cNvPr id="3" name="21,388 eligible recordings">
             <a:extLst xmlns:a="http://schemas.openxmlformats.org/drawingml/2006/main">
               <a:ext uri="{FF2B5EF4-FFF2-40B4-BE49-F238E27FC236}">
-                <a16:creationId xmlns:a16="http://schemas.microsoft.com/office/drawing/2014/main" id="{08272F9D-17F4-439D-AFB2-CB3CAC3D0D6F}"/>
+                <a16:creationId xmlns:a16="http://schemas.microsoft.com/office/drawing/2014/main" id="{6ADD057D-75EE-44E2-91D9-75591DD7A15E}"/>
               </a:ext>
             </a:extLst>
           </p:cNvPr>
@@ -15446,7 +15446,7 @@
           <p:cNvPr id="4" name="12 leads × 1,000 samples at 100 Hz">
             <a:extLst xmlns:a="http://schemas.openxmlformats.org/drawingml/2006/main">
               <a:ext uri="{FF2B5EF4-FFF2-40B4-BE49-F238E27FC236}">
-                <a16:creationId xmlns:a16="http://schemas.microsoft.com/office/drawing/2014/main" id="{895CEF65-4854-4496-9A82-F292396E813D}"/>
+                <a16:creationId xmlns:a16="http://schemas.microsoft.com/office/drawing/2014/main" id="{C0DBF2D4-CEEB-444C-A08C-E84285042AE2}"/>
               </a:ext>
             </a:extLst>
           </p:cNvPr>
@@ -15604,7 +15604,7 @@
           <p:cNvPr id="5" name="">
             <a:extLst xmlns:a="http://schemas.openxmlformats.org/drawingml/2006/main">
               <a:ext uri="{FF2B5EF4-FFF2-40B4-BE49-F238E27FC236}">
-                <a16:creationId xmlns:a16="http://schemas.microsoft.com/office/drawing/2014/main" id="{E3623B26-4CFB-45A3-A8C5-0E400B2994DB}"/>
+                <a16:creationId xmlns:a16="http://schemas.microsoft.com/office/drawing/2014/main" id="{50B97543-5053-41F3-B0EF-100D2F2D01E0}"/>
               </a:ext>
             </a:extLst>
           </p:cNvPr>
@@ -16266,7 +16266,7 @@
           <p:cNvPr id="6" name="411 exclusions from 21,799 source records. No">
             <a:extLst xmlns:a="http://schemas.openxmlformats.org/drawingml/2006/main">
               <a:ext uri="{FF2B5EF4-FFF2-40B4-BE49-F238E27FC236}">
-                <a16:creationId xmlns:a16="http://schemas.microsoft.com/office/drawing/2014/main" id="{ECEE28D3-DE30-4A42-8B4F-326F8076CA01}"/>
+                <a16:creationId xmlns:a16="http://schemas.microsoft.com/office/drawing/2014/main" id="{45D435BF-A5CC-401C-8878-81620A906619}"/>
               </a:ext>
             </a:extLst>
           </p:cNvPr>
@@ -16422,7 +16422,7 @@
     </p:spTree>
     <p:extLst>
       <p:ext uri="{BB962C8B-B14F-4D97-AF65-F5344CB8AC3E}">
-        <p14:creationId xmlns:p14="http://schemas.microsoft.com/office/powerpoint/2010/main" val="514117583"/>
+        <p14:creationId xmlns:p14="http://schemas.microsoft.com/office/powerpoint/2010/main" val="1402962189"/>
       </p:ext>
     </p:extLst>
   </p:cSld>
@@ -16453,7 +16453,7 @@
           <p:cNvPr id="14" name="Experiment workflow">
             <a:extLst xmlns:a="http://schemas.openxmlformats.org/drawingml/2006/main">
               <a:ext uri="{FF2B5EF4-FFF2-40B4-BE49-F238E27FC236}">
-                <a16:creationId xmlns:a16="http://schemas.microsoft.com/office/drawing/2014/main" id="{5935C4C0-3E93-4BE4-A8C4-541535A12F48}"/>
+                <a16:creationId xmlns:a16="http://schemas.microsoft.com/office/drawing/2014/main" id="{602FB7C7-330C-457D-9FBC-811226891883}"/>
               </a:ext>
             </a:extLst>
           </p:cNvPr>
@@ -16611,7 +16611,7 @@
           <p:cNvPr id="2" name="05">
             <a:extLst xmlns:a="http://schemas.openxmlformats.org/drawingml/2006/main">
               <a:ext uri="{FF2B5EF4-FFF2-40B4-BE49-F238E27FC236}">
-                <a16:creationId xmlns:a16="http://schemas.microsoft.com/office/drawing/2014/main" id="{5145AC78-87F1-4509-9E41-AEC23F9C9A60}"/>
+                <a16:creationId xmlns:a16="http://schemas.microsoft.com/office/drawing/2014/main" id="{C480B870-A28B-4702-88D4-A4E6D7E1AA30}"/>
               </a:ext>
             </a:extLst>
           </p:cNvPr>
@@ -16769,7 +16769,7 @@
           <p:cNvPr id="3" name="01">
             <a:extLst xmlns:a="http://schemas.openxmlformats.org/drawingml/2006/main">
               <a:ext uri="{FF2B5EF4-FFF2-40B4-BE49-F238E27FC236}">
-                <a16:creationId xmlns:a16="http://schemas.microsoft.com/office/drawing/2014/main" id="{0D785149-3556-4FCE-8A61-EFACF55F0B06}"/>
+                <a16:creationId xmlns:a16="http://schemas.microsoft.com/office/drawing/2014/main" id="{0CD84594-956B-4FF3-8799-17AA52C4DD28}"/>
               </a:ext>
             </a:extLst>
           </p:cNvPr>
@@ -16927,7 +16927,7 @@
           <p:cNvPr id="4" name="Download 100 Hz waveforms and verify release ">
             <a:extLst xmlns:a="http://schemas.openxmlformats.org/drawingml/2006/main">
               <a:ext uri="{FF2B5EF4-FFF2-40B4-BE49-F238E27FC236}">
-                <a16:creationId xmlns:a16="http://schemas.microsoft.com/office/drawing/2014/main" id="{37119716-B095-4CE1-B3FF-53B13A9E87F3}"/>
+                <a16:creationId xmlns:a16="http://schemas.microsoft.com/office/drawing/2014/main" id="{1ED66528-BC3C-4B86-9F96-677BBED07DAF}"/>
               </a:ext>
             </a:extLst>
           </p:cNvPr>
@@ -17085,7 +17085,7 @@
           <p:cNvPr id="5" name="02">
             <a:extLst xmlns:a="http://schemas.openxmlformats.org/drawingml/2006/main">
               <a:ext uri="{FF2B5EF4-FFF2-40B4-BE49-F238E27FC236}">
-                <a16:creationId xmlns:a16="http://schemas.microsoft.com/office/drawing/2014/main" id="{32F77D1A-F77A-4BB8-A950-1646885C7FC5}"/>
+                <a16:creationId xmlns:a16="http://schemas.microsoft.com/office/drawing/2014/main" id="{24391983-1360-42AE-A125-5C70D044E621}"/>
               </a:ext>
             </a:extLst>
           </p:cNvPr>
@@ -17243,7 +17243,7 @@
           <p:cNvPr id="6" name="Apply official folds and compute normalizatio">
             <a:extLst xmlns:a="http://schemas.openxmlformats.org/drawingml/2006/main">
               <a:ext uri="{FF2B5EF4-FFF2-40B4-BE49-F238E27FC236}">
-                <a16:creationId xmlns:a16="http://schemas.microsoft.com/office/drawing/2014/main" id="{AB83B503-C790-4A82-98D1-0119B19B9236}"/>
+                <a16:creationId xmlns:a16="http://schemas.microsoft.com/office/drawing/2014/main" id="{3EE020C5-C371-445E-9A3D-2080E40488A3}"/>
               </a:ext>
             </a:extLst>
           </p:cNvPr>
@@ -17401,7 +17401,7 @@
           <p:cNvPr id="7" name="03">
             <a:extLst xmlns:a="http://schemas.openxmlformats.org/drawingml/2006/main">
               <a:ext uri="{FF2B5EF4-FFF2-40B4-BE49-F238E27FC236}">
-                <a16:creationId xmlns:a16="http://schemas.microsoft.com/office/drawing/2014/main" id="{CCF273FF-5A2A-4E53-970D-9EC4A35F7313}"/>
+                <a16:creationId xmlns:a16="http://schemas.microsoft.com/office/drawing/2014/main" id="{03A8069C-8EAA-40A5-B162-93284F22EB02}"/>
               </a:ext>
             </a:extLst>
           </p:cNvPr>
@@ -17559,7 +17559,7 @@
           <p:cNvPr id="8" name="Fit models and select checkpoints and thresho">
             <a:extLst xmlns:a="http://schemas.openxmlformats.org/drawingml/2006/main">
               <a:ext uri="{FF2B5EF4-FFF2-40B4-BE49-F238E27FC236}">
-                <a16:creationId xmlns:a16="http://schemas.microsoft.com/office/drawing/2014/main" id="{3B4302D1-424D-498A-9C21-0622E0333344}"/>
+                <a16:creationId xmlns:a16="http://schemas.microsoft.com/office/drawing/2014/main" id="{73C7AD8D-4753-4DD7-8867-4CBD218E4663}"/>
               </a:ext>
             </a:extLst>
           </p:cNvPr>
@@ -17717,7 +17717,7 @@
           <p:cNvPr id="9" name="04">
             <a:extLst xmlns:a="http://schemas.openxmlformats.org/drawingml/2006/main">
               <a:ext uri="{FF2B5EF4-FFF2-40B4-BE49-F238E27FC236}">
-                <a16:creationId xmlns:a16="http://schemas.microsoft.com/office/drawing/2014/main" id="{684DF337-7DF1-4164-9537-469C02280626}"/>
+                <a16:creationId xmlns:a16="http://schemas.microsoft.com/office/drawing/2014/main" id="{05CE6340-F799-49D5-B5C8-D8EC30D7BB6B}"/>
               </a:ext>
             </a:extLst>
           </p:cNvPr>
@@ -17875,7 +17875,7 @@
           <p:cNvPr id="10" name="Freeze selections before evaluating the held-">
             <a:extLst xmlns:a="http://schemas.openxmlformats.org/drawingml/2006/main">
               <a:ext uri="{FF2B5EF4-FFF2-40B4-BE49-F238E27FC236}">
-                <a16:creationId xmlns:a16="http://schemas.microsoft.com/office/drawing/2014/main" id="{64DDD99F-6927-47F5-9D3D-036872667068}"/>
+                <a16:creationId xmlns:a16="http://schemas.microsoft.com/office/drawing/2014/main" id="{9F099157-D410-41D5-9A52-70EDC4445F10}"/>
               </a:ext>
             </a:extLst>
           </p:cNvPr>
@@ -18033,7 +18033,7 @@
           <p:cNvPr id="11" name="05">
             <a:extLst xmlns:a="http://schemas.openxmlformats.org/drawingml/2006/main">
               <a:ext uri="{FF2B5EF4-FFF2-40B4-BE49-F238E27FC236}">
-                <a16:creationId xmlns:a16="http://schemas.microsoft.com/office/drawing/2014/main" id="{125DC2FC-C1EF-4A5D-8BAE-FF6810276A87}"/>
+                <a16:creationId xmlns:a16="http://schemas.microsoft.com/office/drawing/2014/main" id="{1B5C618D-10FA-4C3B-A5B8-3BF38DE329DC}"/>
               </a:ext>
             </a:extLst>
           </p:cNvPr>
@@ -18191,7 +18191,7 @@
           <p:cNvPr id="12" name="Save predictions, metrics, checkpoints, and o">
             <a:extLst xmlns:a="http://schemas.openxmlformats.org/drawingml/2006/main">
               <a:ext uri="{FF2B5EF4-FFF2-40B4-BE49-F238E27FC236}">
-                <a16:creationId xmlns:a16="http://schemas.microsoft.com/office/drawing/2014/main" id="{D92EC10F-0D6A-476E-9547-1E4164F6E1B0}"/>
+                <a16:creationId xmlns:a16="http://schemas.microsoft.com/office/drawing/2014/main" id="{296037CB-3F1D-4AEA-866B-2BC4D9E7BFA4}"/>
               </a:ext>
             </a:extLst>
           </p:cNvPr>
@@ -18349,7 +18349,7 @@
           <p:cNvPr id="13" name="Training statistics and validation selections">
             <a:extLst xmlns:a="http://schemas.openxmlformats.org/drawingml/2006/main">
               <a:ext uri="{FF2B5EF4-FFF2-40B4-BE49-F238E27FC236}">
-                <a16:creationId xmlns:a16="http://schemas.microsoft.com/office/drawing/2014/main" id="{3CCEB2B7-83F3-4260-A7D1-2115F2B7C977}"/>
+                <a16:creationId xmlns:a16="http://schemas.microsoft.com/office/drawing/2014/main" id="{F2B3B0C6-85BF-4CBC-A75C-1890E9B49E9B}"/>
               </a:ext>
             </a:extLst>
           </p:cNvPr>
@@ -18505,7 +18505,7 @@
     </p:spTree>
     <p:extLst>
       <p:ext uri="{BB962C8B-B14F-4D97-AF65-F5344CB8AC3E}">
-        <p14:creationId xmlns:p14="http://schemas.microsoft.com/office/powerpoint/2010/main" val="2019824120"/>
+        <p14:creationId xmlns:p14="http://schemas.microsoft.com/office/powerpoint/2010/main" val="763276962"/>
       </p:ext>
     </p:extLst>
   </p:cSld>
@@ -18536,7 +18536,7 @@
           <p:cNvPr id="5" name="Compact convolutional network">
             <a:extLst xmlns:a="http://schemas.openxmlformats.org/drawingml/2006/main">
               <a:ext uri="{FF2B5EF4-FFF2-40B4-BE49-F238E27FC236}">
-                <a16:creationId xmlns:a16="http://schemas.microsoft.com/office/drawing/2014/main" id="{5A6ED87B-4CBB-4FD8-9A21-DA635868859F}"/>
+                <a16:creationId xmlns:a16="http://schemas.microsoft.com/office/drawing/2014/main" id="{3873743D-4D64-45A5-8DB2-A9B1472BC2A7}"/>
               </a:ext>
             </a:extLst>
           </p:cNvPr>
@@ -18694,7 +18694,7 @@
           <p:cNvPr id="2" name="06">
             <a:extLst xmlns:a="http://schemas.openxmlformats.org/drawingml/2006/main">
               <a:ext uri="{FF2B5EF4-FFF2-40B4-BE49-F238E27FC236}">
-                <a16:creationId xmlns:a16="http://schemas.microsoft.com/office/drawing/2014/main" id="{998824D0-DF7D-4C45-88A8-2996ED8AFD05}"/>
+                <a16:creationId xmlns:a16="http://schemas.microsoft.com/office/drawing/2014/main" id="{A5CA3CCB-8B30-4261-852B-C30B8B1DFAAC}"/>
               </a:ext>
             </a:extLst>
           </p:cNvPr>
@@ -18852,7 +18852,7 @@
           <p:cNvPr id="3" name="">
             <a:extLst xmlns:a="http://schemas.openxmlformats.org/drawingml/2006/main">
               <a:ext uri="{FF2B5EF4-FFF2-40B4-BE49-F238E27FC236}">
-                <a16:creationId xmlns:a16="http://schemas.microsoft.com/office/drawing/2014/main" id="{EE0CBD40-5621-4D01-8F2C-CD73DCC7F7E2}"/>
+                <a16:creationId xmlns:a16="http://schemas.microsoft.com/office/drawing/2014/main" id="{6A4A167C-58E1-4165-A1CB-3C2C48DE4773}"/>
               </a:ext>
             </a:extLst>
           </p:cNvPr>
@@ -19711,7 +19711,7 @@
           <p:cNvPr id="4" name="221,573 trainable parameters. Batch normaliza">
             <a:extLst xmlns:a="http://schemas.openxmlformats.org/drawingml/2006/main">
               <a:ext uri="{FF2B5EF4-FFF2-40B4-BE49-F238E27FC236}">
-                <a16:creationId xmlns:a16="http://schemas.microsoft.com/office/drawing/2014/main" id="{41989460-CACE-4430-935E-33E0CA849C11}"/>
+                <a16:creationId xmlns:a16="http://schemas.microsoft.com/office/drawing/2014/main" id="{8EEB8CC1-FE33-4534-88B6-6F187EA467B7}"/>
               </a:ext>
             </a:extLst>
           </p:cNvPr>
@@ -19867,7 +19867,7 @@
     </p:spTree>
     <p:extLst>
       <p:ext uri="{BB962C8B-B14F-4D97-AF65-F5344CB8AC3E}">
-        <p14:creationId xmlns:p14="http://schemas.microsoft.com/office/powerpoint/2010/main" val="849890984"/>
+        <p14:creationId xmlns:p14="http://schemas.microsoft.com/office/powerpoint/2010/main" val="1377267545"/>
       </p:ext>
     </p:extLst>
   </p:cSld>
@@ -19898,7 +19898,7 @@
           <p:cNvPr id="9" name="Learning objective and decision thresholds">
             <a:extLst xmlns:a="http://schemas.openxmlformats.org/drawingml/2006/main">
               <a:ext uri="{FF2B5EF4-FFF2-40B4-BE49-F238E27FC236}">
-                <a16:creationId xmlns:a16="http://schemas.microsoft.com/office/drawing/2014/main" id="{5AC7E3E2-E1D7-40DF-89DD-39111FC6F75B}"/>
+                <a16:creationId xmlns:a16="http://schemas.microsoft.com/office/drawing/2014/main" id="{034C6DAD-37F1-4736-8B33-05734A04B00F}"/>
               </a:ext>
             </a:extLst>
           </p:cNvPr>
@@ -20056,7 +20056,7 @@
           <p:cNvPr id="2" name="07">
             <a:extLst xmlns:a="http://schemas.openxmlformats.org/drawingml/2006/main">
               <a:ext uri="{FF2B5EF4-FFF2-40B4-BE49-F238E27FC236}">
-                <a16:creationId xmlns:a16="http://schemas.microsoft.com/office/drawing/2014/main" id="{C1735178-0398-43BC-A62F-4CAB710A163C}"/>
+                <a16:creationId xmlns:a16="http://schemas.microsoft.com/office/drawing/2014/main" id="{82B90D3A-EBB8-4EC5-AA1F-9DF018AB2CEB}"/>
               </a:ext>
             </a:extLst>
           </p:cNvPr>
@@ -20214,7 +20214,7 @@
           <p:cNvPr id="3" name="Train-only normalization">
             <a:extLst xmlns:a="http://schemas.openxmlformats.org/drawingml/2006/main">
               <a:ext uri="{FF2B5EF4-FFF2-40B4-BE49-F238E27FC236}">
-                <a16:creationId xmlns:a16="http://schemas.microsoft.com/office/drawing/2014/main" id="{E430C0A3-9882-4D9A-84F8-0E0D5D442A50}"/>
+                <a16:creationId xmlns:a16="http://schemas.microsoft.com/office/drawing/2014/main" id="{04C89DC6-4A33-4CCF-95C8-5CAF30A2B3B6}"/>
               </a:ext>
             </a:extLst>
           </p:cNvPr>
@@ -20372,7 +20372,7 @@
           <p:cNvPr id="4" name="z = (x − μ) / (σ + ε)&#10;Each lead uses frozen t">
             <a:extLst xmlns:a="http://schemas.openxmlformats.org/drawingml/2006/main">
               <a:ext uri="{FF2B5EF4-FFF2-40B4-BE49-F238E27FC236}">
-                <a16:creationId xmlns:a16="http://schemas.microsoft.com/office/drawing/2014/main" id="{7456EF2F-7642-4619-BCEF-05E76158ADD5}"/>
+                <a16:creationId xmlns:a16="http://schemas.microsoft.com/office/drawing/2014/main" id="{705D8441-18E5-4C93-A450-4AD5DA8B5851}"/>
               </a:ext>
             </a:extLst>
           </p:cNvPr>
@@ -20553,7 +20553,7 @@
           <p:cNvPr id="5" name="Weighted binary cross entropy">
             <a:extLst xmlns:a="http://schemas.openxmlformats.org/drawingml/2006/main">
               <a:ext uri="{FF2B5EF4-FFF2-40B4-BE49-F238E27FC236}">
-                <a16:creationId xmlns:a16="http://schemas.microsoft.com/office/drawing/2014/main" id="{D017EF21-52A6-4FB6-93AC-1DF6EFE0A309}"/>
+                <a16:creationId xmlns:a16="http://schemas.microsoft.com/office/drawing/2014/main" id="{D08D3206-FE5A-431E-8F04-B0F3AE3B54C0}"/>
               </a:ext>
             </a:extLst>
           </p:cNvPr>
@@ -20711,7 +20711,7 @@
           <p:cNvPr id="6" name="ℓ = −w y log(p) − (1 − y) log(1 − p)&#10;Training">
             <a:extLst xmlns:a="http://schemas.openxmlformats.org/drawingml/2006/main">
               <a:ext uri="{FF2B5EF4-FFF2-40B4-BE49-F238E27FC236}">
-                <a16:creationId xmlns:a16="http://schemas.microsoft.com/office/drawing/2014/main" id="{5831C443-F7AF-4D89-8C22-3BF7706ECBE8}"/>
+                <a16:creationId xmlns:a16="http://schemas.microsoft.com/office/drawing/2014/main" id="{D3C3912D-32F0-4D82-9120-210DD91F22B4}"/>
               </a:ext>
             </a:extLst>
           </p:cNvPr>
@@ -20892,7 +20892,7 @@
           <p:cNvPr id="7" name="Validation-selected thresholds">
             <a:extLst xmlns:a="http://schemas.openxmlformats.org/drawingml/2006/main">
               <a:ext uri="{FF2B5EF4-FFF2-40B4-BE49-F238E27FC236}">
-                <a16:creationId xmlns:a16="http://schemas.microsoft.com/office/drawing/2014/main" id="{91559460-3849-46BE-A5BA-CE0F76B29D8D}"/>
+                <a16:creationId xmlns:a16="http://schemas.microsoft.com/office/drawing/2014/main" id="{5C9F53B8-7E3E-403B-BEB4-5995A89738FB}"/>
               </a:ext>
             </a:extLst>
           </p:cNvPr>
@@ -21050,7 +21050,7 @@
           <p:cNvPr id="8" name="Independent sigmoid scores allow overlapping ">
             <a:extLst xmlns:a="http://schemas.openxmlformats.org/drawingml/2006/main">
               <a:ext uri="{FF2B5EF4-FFF2-40B4-BE49-F238E27FC236}">
-                <a16:creationId xmlns:a16="http://schemas.microsoft.com/office/drawing/2014/main" id="{3C962794-ECB8-4E0B-811C-33DE7EBC62C8}"/>
+                <a16:creationId xmlns:a16="http://schemas.microsoft.com/office/drawing/2014/main" id="{DBEBEBAE-E701-41F2-A0F4-F83BF2D5466F}"/>
               </a:ext>
             </a:extLst>
           </p:cNvPr>
@@ -21229,7 +21229,7 @@
     </p:spTree>
     <p:extLst>
       <p:ext uri="{BB962C8B-B14F-4D97-AF65-F5344CB8AC3E}">
-        <p14:creationId xmlns:p14="http://schemas.microsoft.com/office/powerpoint/2010/main" val="1330461194"/>
+        <p14:creationId xmlns:p14="http://schemas.microsoft.com/office/powerpoint/2010/main" val="690294700"/>
       </p:ext>
     </p:extLst>
   </p:cSld>
@@ -21260,7 +21260,7 @@
           <p:cNvPr id="6" name="Training protocol and comparison models">
             <a:extLst xmlns:a="http://schemas.openxmlformats.org/drawingml/2006/main">
               <a:ext uri="{FF2B5EF4-FFF2-40B4-BE49-F238E27FC236}">
-                <a16:creationId xmlns:a16="http://schemas.microsoft.com/office/drawing/2014/main" id="{4F3D8D1D-41FA-4F43-A35A-DB3D7BDB6B63}"/>
+                <a16:creationId xmlns:a16="http://schemas.microsoft.com/office/drawing/2014/main" id="{BA7F7DB6-4A00-4A61-B6FD-F7CA7FDBDB44}"/>
               </a:ext>
             </a:extLst>
           </p:cNvPr>
@@ -21418,7 +21418,7 @@
           <p:cNvPr id="2" name="08">
             <a:extLst xmlns:a="http://schemas.openxmlformats.org/drawingml/2006/main">
               <a:ext uri="{FF2B5EF4-FFF2-40B4-BE49-F238E27FC236}">
-                <a16:creationId xmlns:a16="http://schemas.microsoft.com/office/drawing/2014/main" id="{0A25029B-058D-413A-9381-6EAF19F9D5E5}"/>
+                <a16:creationId xmlns:a16="http://schemas.microsoft.com/office/drawing/2014/main" id="{41973547-ABA9-4095-B232-017E6A93C10B}"/>
               </a:ext>
             </a:extLst>
           </p:cNvPr>
@@ -21576,7 +21576,7 @@
           <p:cNvPr id="3" name="">
             <a:extLst xmlns:a="http://schemas.openxmlformats.org/drawingml/2006/main">
               <a:ext uri="{FF2B5EF4-FFF2-40B4-BE49-F238E27FC236}">
-                <a16:creationId xmlns:a16="http://schemas.microsoft.com/office/drawing/2014/main" id="{61144EFA-60FB-467F-B476-53E9C6D31965}"/>
+                <a16:creationId xmlns:a16="http://schemas.microsoft.com/office/drawing/2014/main" id="{9E4BCDCC-9BD4-471C-8758-50C612CBADD9}"/>
               </a:ext>
             </a:extLst>
           </p:cNvPr>
@@ -22176,7 +22176,7 @@
           <p:cNvPr id="4" name="12 neural runs and one logistic feature basel">
             <a:extLst xmlns:a="http://schemas.openxmlformats.org/drawingml/2006/main">
               <a:ext uri="{FF2B5EF4-FFF2-40B4-BE49-F238E27FC236}">
-                <a16:creationId xmlns:a16="http://schemas.microsoft.com/office/drawing/2014/main" id="{CBADAA65-7D9B-4518-8334-06B6E2DBAA75}"/>
+                <a16:creationId xmlns:a16="http://schemas.microsoft.com/office/drawing/2014/main" id="{138D99E5-E3C2-4373-B921-7FD6D493678E}"/>
               </a:ext>
             </a:extLst>
           </p:cNvPr>
@@ -22334,7 +22334,7 @@
           <p:cNvPr id="5" name="Windows, Python 3.12.14, PyTorch 2.14.1+cpu. ">
             <a:extLst xmlns:a="http://schemas.openxmlformats.org/drawingml/2006/main">
               <a:ext uri="{FF2B5EF4-FFF2-40B4-BE49-F238E27FC236}">
-                <a16:creationId xmlns:a16="http://schemas.microsoft.com/office/drawing/2014/main" id="{9200932D-517A-490D-8A09-7B1FB0D9521D}"/>
+                <a16:creationId xmlns:a16="http://schemas.microsoft.com/office/drawing/2014/main" id="{8DE157A3-F993-41FC-9DBB-2DFD557FBBDC}"/>
               </a:ext>
             </a:extLst>
           </p:cNvPr>
@@ -22490,7 +22490,7 @@
     </p:spTree>
     <p:extLst>
       <p:ext uri="{BB962C8B-B14F-4D97-AF65-F5344CB8AC3E}">
-        <p14:creationId xmlns:p14="http://schemas.microsoft.com/office/powerpoint/2010/main" val="1085472378"/>
+        <p14:creationId xmlns:p14="http://schemas.microsoft.com/office/powerpoint/2010/main" val="1283328877"/>
       </p:ext>
     </p:extLst>
   </p:cSld>
@@ -22521,7 +22521,7 @@
           <p:cNvPr id="6" name="Measured performance on held-out patients">
             <a:extLst xmlns:a="http://schemas.openxmlformats.org/drawingml/2006/main">
               <a:ext uri="{FF2B5EF4-FFF2-40B4-BE49-F238E27FC236}">
-                <a16:creationId xmlns:a16="http://schemas.microsoft.com/office/drawing/2014/main" id="{5CEEBF46-B656-4F2C-AABE-82B92757E60B}"/>
+                <a16:creationId xmlns:a16="http://schemas.microsoft.com/office/drawing/2014/main" id="{4DDCFFBB-8453-4F00-9BC4-C21A7E599023}"/>
               </a:ext>
             </a:extLst>
           </p:cNvPr>
@@ -22679,7 +22679,7 @@
           <p:cNvPr id="2" name="09">
             <a:extLst xmlns:a="http://schemas.openxmlformats.org/drawingml/2006/main">
               <a:ext uri="{FF2B5EF4-FFF2-40B4-BE49-F238E27FC236}">
-                <a16:creationId xmlns:a16="http://schemas.microsoft.com/office/drawing/2014/main" id="{4F0712FD-A7D7-4442-9A43-6FEA912CB1B3}"/>
+                <a16:creationId xmlns:a16="http://schemas.microsoft.com/office/drawing/2014/main" id="{49042EF5-6063-407C-B7ED-7522D4F50980}"/>
               </a:ext>
             </a:extLst>
           </p:cNvPr>
@@ -22837,7 +22837,7 @@
           <p:cNvPr id="3" name="">
             <a:extLst xmlns:a="http://schemas.openxmlformats.org/drawingml/2006/main">
               <a:ext uri="{FF2B5EF4-FFF2-40B4-BE49-F238E27FC236}">
-                <a16:creationId xmlns:a16="http://schemas.microsoft.com/office/drawing/2014/main" id="{369C6DA6-7654-426D-96EE-0DB765B16DED}"/>
+                <a16:creationId xmlns:a16="http://schemas.microsoft.com/office/drawing/2014/main" id="{1907455B-4E1E-4704-B168-B4AAF78C3FE1}"/>
               </a:ext>
             </a:extLst>
           </p:cNvPr>
@@ -23803,7 +23803,7 @@
           <p:cNvPr id="4" name="Class weighting did not improve average perfo">
             <a:extLst xmlns:a="http://schemas.openxmlformats.org/drawingml/2006/main">
               <a:ext uri="{FF2B5EF4-FFF2-40B4-BE49-F238E27FC236}">
-                <a16:creationId xmlns:a16="http://schemas.microsoft.com/office/drawing/2014/main" id="{45872B7A-C77B-4B9A-A5B6-F0440364D915}"/>
+                <a16:creationId xmlns:a16="http://schemas.microsoft.com/office/drawing/2014/main" id="{38E4A44E-69D2-427A-93F5-6B6CBDA4BB0D}"/>
               </a:ext>
             </a:extLst>
           </p:cNvPr>
@@ -23961,7 +23961,7 @@
           <p:cNvPr id="5" name="Neural values: mean ± sample SD over three se">
             <a:extLst xmlns:a="http://schemas.openxmlformats.org/drawingml/2006/main">
               <a:ext uri="{FF2B5EF4-FFF2-40B4-BE49-F238E27FC236}">
-                <a16:creationId xmlns:a16="http://schemas.microsoft.com/office/drawing/2014/main" id="{11197F9A-EF96-4F14-93A1-74B7EB38896A}"/>
+                <a16:creationId xmlns:a16="http://schemas.microsoft.com/office/drawing/2014/main" id="{13CF6785-3743-41E1-9D68-DE9B073835DE}"/>
               </a:ext>
             </a:extLst>
           </p:cNvPr>
@@ -24117,7 +24117,7 @@
     </p:spTree>
     <p:extLst>
       <p:ext uri="{BB962C8B-B14F-4D97-AF65-F5344CB8AC3E}">
-        <p14:creationId xmlns:p14="http://schemas.microsoft.com/office/powerpoint/2010/main" val="1862430657"/>
+        <p14:creationId xmlns:p14="http://schemas.microsoft.com/office/powerpoint/2010/main" val="49180623"/>
       </p:ext>
     </p:extLst>
   </p:cSld>

</xml_diff>